<commit_message>
docs: evidence-first README and an up-to-date deck
README: a judge quick-start, what's new, every result tagged MEASURED or
ESTIMATE with its date and a link to the raw results in docs/evidence/
(answer-key runs, the dataset metrics, the real-platform scout), what is
real and what is simulated, how Gen AI is used, and what breaks first.

Deck: a Fix it slide with a Gemini verify run (9 of 9 fixes verified,
₹1,894 → ₹1,596); the 26 self-declared platforms; the agent graph, Fix it
and the CCPA self-audit among the features; gemini-3.6-flash, F1 0.959,
~27 s and 213 + 44 tests in the numbers; speaker notes to match.
</commit_message>
<xml_diff>
--- a/Zero Context - Shop Honest - AI Builder Cup.pptx
+++ b/Zero Context - Shop Honest - AI Builder Cup.pptx
@@ -18,6 +18,7 @@
     <p:sldId id="264" r:id="rId14"/>
     <p:sldId id="265" r:id="rId15"/>
     <p:sldId id="266" r:id="rId16"/>
+    <p:sldId id="272" r:id="rId28"/>
     <p:sldId id="267" r:id="rId17"/>
     <p:sldId id="268" r:id="rId18"/>
     <p:sldId id="269" r:id="rId19"/>
@@ -368,7 +369,7 @@
                         </a:solidFill>
                         <a:latin typeface="Google Sans Flex"/>
                       </a:rPr>
-                      <a:t>0.962</a:t>
+                      <a:t>0.959</a:t>
                     </a:r>
                   </a:p>
                 </c:rich>
@@ -470,7 +471,7 @@
                 <c:formatCode>General</c:formatCode>
                 <c:ptCount val="3"/>
                 <c:pt idx="0">
-                  <c:v>0.962</c:v>
+                  <c:v>0.959</c:v>
                 </c:pt>
                 <c:pt idx="1">
                   <c:v>0.975</c:v>
@@ -720,7 +721,7 @@
 (local)</c:v>
                 </c:pt>
                 <c:pt idx="2">
-                  <c:v>+ Gemini 3.8
+                  <c:v>+ Gemini 3.6
 Flash</c:v>
                 </c:pt>
               </c:strCache>
@@ -1408,7 +1409,7 @@
           <a:lstStyle/>
           <a:p>
             <a:r>
-              <a:t>A live audit costs about ₹2: roughly 17k input and 7k output tokens on Gemini 3.8 Flash plus ~45 s of Cloud Run. Replays cost nothing, and Cloud Run scales to zero when idle. Estimates: ₹2,000 a month for 1,000 audits, ₹20,000 for 10,000. Guardrails: a 100-a-day live cap, per-audit token/call/time budgets, budget alerts.</a:t>
+              <a:t>A live audit of Store A uses about 21k input and 5k output tokens on Gemini 3.6 Flash (measured) and about 30 s of Cloud Run. The rupee figures are estimates: about ₹2 per live audit was measured on 3.8 Flash. Replays, and Fix it on a replay, cost nothing; verifying fixes is one live audit. Cloud Run scales to zero when idle. Guardrails: a 100-a-day live cap, per-audit token, call and time budgets, budget alerts.</a:t>
             </a:r>
           </a:p>
         </p:txBody>
@@ -1586,7 +1587,7 @@
           <a:lstStyle/>
           <a:p>
             <a:r>
-              <a:t>Planted tricks: 9/9 on the rigged store with the borderline claim sent to review, 0 false alarms on the honest store, 6/6 before the sign-in wall. Public dataset (ec-darkpattern, Yada et al. 2022, 2,356 texts): zero-shot F1 0.962 with precision 0.998, against 0.960–0.975 for models trained on it. Ablation on Store A: measured checks 6/9, with Gemma 3 4B 8/9, with Gemini 3.8 Flash 9/9. Flash matched 2.5 Pro and 3.1 Pro and was fastest (~40 s).</a:t>
+              <a:t>Planted tricks: 9/9 on the rigged store with the borderline claim sent to review, 0 false alarms on the honest store, 6/6 before the sign-in wall (gemini-3.6-flash, agent graph on, repeated 15–16 Oct). Public dataset (ec-darkpattern, Yada et al. 2022, 2,356 texts): zero-shot F1 0.959 with precision 0.997 (3 false alarms), against 0.960–0.975 for models trained on it. Ablation on Store A: measured checks 6/9, with Gemma 3 4B 8/9, with Gemini 3.6 Flash 9/9, in about 27 s. Fix it: with every fix applied to a copy of Store A, the re-audit found 9 of 9 gone, trust 16 → 100, ₹1,894 → ₹1,596.</a:t>
             </a:r>
           </a:p>
         </p:txBody>
@@ -1675,7 +1676,7 @@
           <a:lstStyle/>
           <a:p>
             <a:r>
-              <a:t>Next: bring-your-own-key live audits, logged-in journeys with test accounts in Secret Manager, scheduled monitoring with Cloud Scheduler. Later: a shopper browser extension, a regulator dashboard on BigQuery and Looker Studio, mobile apps and Indian-language pages.</a:t>
+              <a:t>Next: audit all 26 self-declared platforms logged out (we scouted six: two reach the cart, the rest block automated browsers, and we report that honestly), logged-in journeys with test accounts in Secret Manager, nightly re-audits and a CI check. Later: a shopper browser extension, a regulator dashboard on BigQuery and Looker Studio, mobile apps and Indian-language pages.</a:t>
             </a:r>
           </a:p>
         </p:txBody>
@@ -1853,7 +1854,7 @@
           <a:lstStyle/>
           <a:p>
             <a:r>
-              <a:t>Responsible by design: the agent never pays, signs in, types, accepts terms or bypasses bot protection. Findings must cite measured elements, are double-checked, and go to human review when unsure. On real stores, layout-based findings go to review and reports carry a not-a-legal-finding note.</a:t>
+              <a:t>Responsible by design: the agent never pays, signs in, types, accepts terms or bypasses bot protection, and never presses another product's button. Findings must cite measured elements, are double-checked by an agent with tools, and go to human review when unsure. On real stores, layout-based findings go to review and reports carry a not-a-legal-finding note; a page it couldn't check is 'not checked', never 'clean'. Fix it never touches a real site: fixes run on a copy of our own demo store, in the auditor's browser only.</a:t>
             </a:r>
           </a:p>
         </p:txBody>
@@ -2031,7 +2032,7 @@
           <a:lstStyle/>
           <a:p>
             <a:r>
-              <a:t>Problem: dark patterns make shoppers pay more than the price they saw. In our demo store the page says ₹1,499 and payment asks ₹1,894. ASCI found deceptive design in 52 of the top 53 Indian apps (2024); CCPA's 2023 guidelines ban 13 patterns, and its June 2025 advisory asked e-commerce platforms to self-audit within 3 months. Idea: Shop Honest's agents walk product → variant → cart → checkout → payment like a shopper and report each trick with screenshot evidence, the rule, the money impact and a fix.</a:t>
+              <a:t>Problem: dark patterns make shoppers pay more than the price they saw. In our demo store the page says ₹1,499 and payment asks ₹1,894. ASCI found deceptive design in 52 of the top 53 Indian apps (2024); CCPA's 2023 guidelines ban 13 patterns. In November 2025, 26 platforms declared themselves free of dark patterns; in August 2026 CCPA fined nine platforms, including Zepto, one of the 26. Self-declaration isn't enough. Idea: Shop Honest's agents walk product → variant → cart → checkout → payment like a shopper and report each trick with screenshot evidence, the rule, the money impact and a fix, then prove the fix worked.</a:t>
             </a:r>
           </a:p>
         </p:txBody>
@@ -2120,7 +2121,7 @@
           <a:lstStyle/>
           <a:p>
             <a:r>
-              <a:t>Different: a whole-journey, measured audit in a real browser, not a single-page or text scan. Solves: platforms can self-audit, regulators and consumer groups get evidence at scale, shoppers see the real price. USP: every claim is grounded on a measured element and double-checked, findings come with ₹ impact, law and fixes, and partial audits say what they couldn't see.</a:t>
+              <a:t>Different: a whole-journey, measured audit in a real browser, not a single-page or text scan, and it doesn't stop at finding: it fixes and re-audits. Solves: platforms get a real self-audit instead of a self-declaration, regulators and consumer groups get evidence at scale, shoppers see the real price. USP: every claim is grounded on a measured element and double-checked by an agent with tools; findings come with ₹ impact, law and fixes; a page it couldn't check is 'not checked', never 'clean'. Proof: 9/9 tricks, 0 false alarms, 9/9 fixes verified, F1 0.959 zero-shot.</a:t>
             </a:r>
           </a:p>
         </p:txBody>
@@ -2209,7 +2210,7 @@
           <a:lstStyle/>
           <a:p>
             <a:r>
-              <a:t>Eight features: live walkthrough, measured checks, Price Historian on BigQuery, Gemini Pattern Analyst, Adjudicator with a human review queue, the real bill, law and fixes across 7 regions, and reports/PDF for any store.</a:t>
+              <a:t>Eight features: the live walkthrough; measured checks; the Price Historian on BigQuery; the ADK agent graph, where Gemini reads each screen and an Adjudicator agent checks evidence with tools; Fix it, which proposes a fix per finding, projects the impact and verifies it on a copy of the store; the real bill; the law in 7 regions plus a 13-pattern CCPA self-audit PDF; and reports for any public store, logged out.</a:t>
             </a:r>
           </a:p>
         </p:txBody>
@@ -2476,7 +2477,7 @@
           <a:lstStyle/>
           <a:p>
             <a:r>
-              <a:t>Firebase Hosting serves the React app and proxies /api to Cloud Run (FastAPI). The live event stream goes straight to Cloud Run because Hosting buffers streams. Each audit runs a Playwright Chromium navigator and ADK agents on Gemini via Vertex AI (gemini-3.8-flash, falling back to 2.5-flash). Firestore keeps audits and a resumable event log, Cloud Storage the screenshots, BigQuery the price history. Cloud Build and Artifact Registry ship images; Cloud Monitoring and billing budgets watch it.</a:t>
+              <a:t>Firebase Hosting serves the React app and the demo stores, and proxies /api to Cloud Run (FastAPI). The live event stream goes straight to Cloud Run because Hosting buffers streams. Each audit runs a Playwright Chromium navigator and an ADK agent graph on Gemini via Vertex AI (gemini-3.6-flash, falling back to gemini-3.1-flash-lite): the Pattern Analyst, the Adjudicator with evidence tools, and the Fixer. Firestore keeps audits and a resumable event log, Cloud Storage the screenshots, BigQuery the price history. Cloud Build and Artifact Registry ship images; Cloud Monitoring and billing budgets watch it.</a:t>
             </a:r>
           </a:p>
         </p:txBody>
@@ -2565,7 +2566,7 @@
           <a:lstStyle/>
           <a:p>
             <a:r>
-              <a:t>AI: Gemini 3.8 Flash on Vertex AI through Google's Agent Development Kit; Gemma 3 4B via Ollama for offline development. Google Cloud: Cloud Run, Firestore, Cloud Storage, BigQuery, Cloud Build, Artifact Registry, Cloud Monitoring, Billing budgets, Firebase Hosting. App: Python 3.12, FastAPI, Playwright, Pydantic, React 19, TypeScript, Vite, Tailwind, three.js.</a:t>
+              <a:t>AI: Gemini 3.6 Flash on Vertex AI through Google's Agent Development Kit, run as an agent graph with tools; Gemma 3 4B via Ollama for offline development. Google Cloud: Cloud Run, Firestore, Cloud Storage, BigQuery, Cloud Build, Artifact Registry, Cloud Monitoring, Billing budgets, Firebase Hosting. App: Python 3.12, FastAPI, Playwright, Pydantic, React 19, TypeScript, Vite, Tailwind, three.js.</a:t>
             </a:r>
           </a:p>
         </p:txBody>
@@ -8077,7 +8078,7 @@
                 </a:solidFill>
                 <a:latin typeface="Google Sans Flex Medium"/>
               </a:rPr>
-              <a:t>a full journey: 5 steps, about 40 seconds</a:t>
+              <a:t>a full journey: 5 steps, about 30 seconds</a:t>
             </a:r>
           </a:p>
         </p:txBody>
@@ -8154,7 +8155,7 @@
                 </a:solidFill>
                 <a:latin typeface="Google Sans Flex"/>
               </a:rPr>
-              <a:t>Gemini 3.8 Flash</a:t>
+              <a:t>Gemini 3.6 Flash</a:t>
             </a:r>
           </a:p>
           <a:p>
@@ -8173,7 +8174,7 @@
                 </a:solidFill>
                 <a:latin typeface="Google Sans Flex"/>
               </a:rPr>
-              <a:t>~17k in + 7k out tokens</a:t>
+              <a:t>~21k in + 5k out tokens</a:t>
             </a:r>
           </a:p>
         </p:txBody>
@@ -8311,7 +8312,7 @@
                 </a:solidFill>
                 <a:latin typeface="Google Sans Flex"/>
               </a:rPr>
-              <a:t>~45 s on 2 vCPU</a:t>
+              <a:t>~30 s on 2 vCPU</a:t>
             </a:r>
           </a:p>
         </p:txBody>
@@ -12065,7 +12066,7 @@
                 </a:solidFill>
                 <a:latin typeface="Google Sans Flex"/>
               </a:rPr>
-              <a:t>0.998</a:t>
+              <a:t>0.997</a:t>
             </a:r>
             <a:r>
               <a:rPr sz="1000" b="0">
@@ -12093,7 +12094,7 @@
                 </a:solidFill>
                 <a:latin typeface="Google Sans Flex"/>
               </a:rPr>
-              <a:t>2 false alarms in 2,356 texts. Our model never saw this dataset; the others were trained on it.</a:t>
+              <a:t>3 false alarms in 2,356 texts. Our model never saw this dataset; the others were trained on it.</a:t>
             </a:r>
           </a:p>
         </p:txBody>
@@ -12294,7 +12295,7 @@
                 </a:solidFill>
                 <a:latin typeface="Google Sans Flex"/>
               </a:rPr>
-              <a:t>~40 s</a:t>
+              <a:t>~27 s</a:t>
             </a:r>
             <a:r>
               <a:rPr sz="1000" b="0">
@@ -12322,7 +12323,7 @@
                 </a:solidFill>
                 <a:latin typeface="Google Sans Flex"/>
               </a:rPr>
-              <a:t>2.5 Pro and 3.1 Pro also scored 9/9 but took 49 s and 58 s, so Flash runs both tiers.</a:t>
+              <a:t>2.5 Pro, 3.1 Pro and 3.8 Flash also scored 9/9 but were slower, so 3.6 Flash runs both tiers.</a:t>
             </a:r>
           </a:p>
         </p:txBody>
@@ -12419,7 +12420,7 @@
                 </a:solidFill>
                 <a:latin typeface="Google Sans Flex"/>
               </a:rPr>
-              <a:t>137 backend tests · every live event validated against the API contract · end-to-end pre-flight on production: 6/6</a:t>
+              <a:t>213 backend + 44 web tests · Fix it: 9/9 fixes verified on a copy · every event checked against the API contract · pre-flight 6/6</a:t>
             </a:r>
           </a:p>
         </p:txBody>
@@ -12781,7 +12782,7 @@
       </p:sp>
       <p:pic>
         <p:nvPicPr>
-          <p:cNvPr id="156" name="Picture 155" descr="l-key-round-ink.png"/>
+          <p:cNvPr id="156" name="Picture 155" descr="l-list-checks-ink.png"/>
           <p:cNvPicPr>
             <a:picLocks noChangeAspect="1"/>
           </p:cNvPicPr>
@@ -12897,7 +12898,7 @@
                 </a:solidFill>
                 <a:latin typeface="Google Sans Flex"/>
               </a:rPr>
-              <a:t>Bring your own key</a:t>
+              <a:t>The 26, audited</a:t>
             </a:r>
           </a:p>
         </p:txBody>
@@ -12939,7 +12940,7 @@
                 </a:solidFill>
                 <a:latin typeface="Google Sans Flex"/>
               </a:rPr>
-              <a:t>Live audits on your own Gemini or Claude key, used for one run and never stored.</a:t>
+              <a:t>All 26 self-declared platforms, logged out, each finding checked by a person.</a:t>
             </a:r>
           </a:p>
         </p:txBody>
@@ -13629,7 +13630,7 @@
                 </a:solidFill>
                 <a:latin typeface="Google Sans Flex"/>
               </a:rPr>
-              <a:t>Nightly audits with Cloud Scheduler; an alert the day a store adds a new trick.</a:t>
+              <a:t>Nightly re-audits with Cloud Scheduler, and a CI check that fails a deploy adding a trick.</a:t>
             </a:r>
           </a:p>
         </p:txBody>
@@ -16953,7 +16954,7 @@
                 </a:solidFill>
                 <a:latin typeface="Google Sans Flex"/>
               </a:rPr>
-              <a:t>a second Gemini pass on a crop of the evidence.</a:t>
+              <a:t>a second agent re-checks the evidence with tools.</a:t>
             </a:r>
           </a:p>
         </p:txBody>
@@ -17319,7 +17320,7 @@
                 </a:solidFill>
                 <a:latin typeface="Google Sans Flex"/>
               </a:rPr>
-              <a:t>host allowlist + SSRF guard  ·  ad networks blocked  ·  per-audit token and time budgets  ·  daily cap  ·  billing alerts</a:t>
+              <a:t>SSRF guard  ·  ad networks blocked  ·  per-audit budgets  ·  daily cap  ·  Fix it runs only on a copy, in our own browser</a:t>
             </a:r>
           </a:p>
         </p:txBody>
@@ -17412,6 +17413,437 @@
 </p:sld>
 </file>
 
+<file path=ppt/slides/slide17.xml><?xml version="1.0" encoding="utf-8"?>
+<p:sld xmlns:a="http://schemas.openxmlformats.org/drawingml/2006/main" xmlns:r="http://schemas.openxmlformats.org/officeDocument/2006/relationships" xmlns:mc="http://schemas.openxmlformats.org/markup-compatibility/2006" xmlns:mv="urn:schemas-microsoft-com:mac:vml" xmlns:p="http://schemas.openxmlformats.org/presentationml/2006/main" xmlns:c="http://schemas.openxmlformats.org/drawingml/2006/chart" xmlns:dgm="http://schemas.openxmlformats.org/drawingml/2006/diagram" xmlns:o="urn:schemas-microsoft-com:office:office" xmlns:v="urn:schemas-microsoft-com:vml" xmlns:pvml="urn:schemas-microsoft-com:office:powerpoint" xmlns:com="http://schemas.openxmlformats.org/drawingml/2006/compatibility" xmlns:p14="http://schemas.microsoft.com/office/powerpoint/2010/main" xmlns:p15="http://schemas.microsoft.com/office/powerpoint/2012/main" xmlns:ahyp="http://schemas.microsoft.com/office/drawing/2018/hyperlinkcolor">
+  <p:cSld>
+    <p:spTree>
+      <p:nvGrpSpPr>
+        <p:cNvPr id="131" name="Shape 131"/>
+        <p:cNvGrpSpPr/>
+        <p:nvPr/>
+      </p:nvGrpSpPr>
+      <p:grpSpPr>
+        <a:xfrm>
+          <a:off x="0" y="0"/>
+          <a:ext cx="0" cy="0"/>
+          <a:chOff x="0" y="0"/>
+          <a:chExt cx="0" cy="0"/>
+        </a:xfrm>
+      </p:grpSpPr>
+      <p:pic>
+        <p:nvPicPr>
+          <p:cNvPr id="132" name="Google Shape;132;p23" title="Frame 144.png"/>
+          <p:cNvPicPr preferRelativeResize="0"/>
+          <p:nvPr/>
+        </p:nvPicPr>
+        <p:blipFill rotWithShape="1">
+          <a:blip r:embed="rId3">
+            <a:alphaModFix/>
+          </a:blip>
+          <a:srcRect b="98001" l="0" r="0" t="0"/>
+          <a:stretch/>
+        </p:blipFill>
+        <p:spPr>
+          <a:xfrm>
+            <a:off x="0" y="5093562"/>
+            <a:ext cx="9144000" cy="54275"/>
+          </a:xfrm>
+          <a:prstGeom prst="rect">
+            <a:avLst/>
+          </a:prstGeom>
+          <a:noFill/>
+          <a:ln>
+            <a:noFill/>
+          </a:ln>
+        </p:spPr>
+      </p:pic>
+      <p:pic>
+        <p:nvPicPr>
+          <p:cNvPr id="133" name="Google Shape;133;p23" title="Group 427319979.png"/>
+          <p:cNvPicPr preferRelativeResize="0"/>
+          <p:nvPr/>
+        </p:nvPicPr>
+        <p:blipFill>
+          <a:blip r:embed="rId4">
+            <a:alphaModFix/>
+          </a:blip>
+          <a:stretch>
+            <a:fillRect/>
+          </a:stretch>
+        </p:blipFill>
+        <p:spPr>
+          <a:xfrm>
+            <a:off x="0" y="1"/>
+            <a:ext cx="9144000" cy="507359"/>
+          </a:xfrm>
+          <a:prstGeom prst="rect">
+            <a:avLst/>
+          </a:prstGeom>
+          <a:noFill/>
+          <a:ln>
+            <a:noFill/>
+          </a:ln>
+        </p:spPr>
+      </p:pic>
+      <p:sp>
+        <p:nvSpPr>
+          <p:cNvPr id="134" name="Google Shape;134;p23"/>
+          <p:cNvSpPr/>
+          <p:nvPr/>
+        </p:nvSpPr>
+        <p:spPr>
+          <a:xfrm>
+            <a:off x="-29250" y="5071875"/>
+            <a:ext cx="9173400" cy="97800"/>
+          </a:xfrm>
+          <a:prstGeom prst="rect">
+            <a:avLst/>
+          </a:prstGeom>
+          <a:solidFill>
+            <a:schemeClr val="dk1"/>
+          </a:solidFill>
+          <a:ln>
+            <a:noFill/>
+          </a:ln>
+        </p:spPr>
+        <p:txBody>
+          <a:bodyPr anchorCtr="0" anchor="ctr" bIns="91425" lIns="91425" spcFirstLastPara="1" rIns="91425" wrap="square" tIns="91425">
+            <a:noAutofit/>
+          </a:bodyPr>
+          <a:lstStyle/>
+          <a:p>
+            <a:pPr indent="0" lvl="0" marL="0" rtl="0" algn="ctr">
+              <a:spcBef>
+                <a:spcPts val="0"/>
+              </a:spcBef>
+              <a:spcAft>
+                <a:spcPts val="0"/>
+              </a:spcAft>
+              <a:buNone/>
+            </a:pPr>
+            <a:r>
+              <a:t/>
+            </a:r>
+            <a:endParaRPr/>
+          </a:p>
+        </p:txBody>
+      </p:sp>
+      <p:sp>
+        <p:nvSpPr>
+          <p:cNvPr id="135" name="Google Shape;135;p23"/>
+          <p:cNvSpPr txBox="1"/>
+          <p:nvPr/>
+        </p:nvSpPr>
+        <p:spPr>
+          <a:xfrm>
+            <a:off x="265350" y="663825"/>
+            <a:ext cx="8943000" cy="561900"/>
+          </a:xfrm>
+          <a:prstGeom prst="rect">
+            <a:avLst/>
+          </a:prstGeom>
+          <a:noFill/>
+          <a:ln>
+            <a:noFill/>
+          </a:ln>
+        </p:spPr>
+        <p:txBody>
+          <a:bodyPr anchorCtr="0" anchor="t" bIns="91425" lIns="91425" spcFirstLastPara="1" rIns="91425" wrap="square" tIns="91425">
+            <a:noAutofit/>
+          </a:bodyPr>
+          <a:lstStyle/>
+          <a:p>
+            <a:pPr indent="0" lvl="0" marL="0" rtl="0" algn="l">
+              <a:spcBef>
+                <a:spcPts val="0"/>
+              </a:spcBef>
+              <a:spcAft>
+                <a:spcPts val="0"/>
+              </a:spcAft>
+              <a:buNone/>
+            </a:pPr>
+            <a:r>
+              <a:rPr lang="en-GB" sz="1600">
+                <a:latin typeface="Google Sans Flex Medium"/>
+                <a:ea typeface="Google Sans Flex Medium"/>
+                <a:cs typeface="Google Sans Flex Medium"/>
+                <a:sym typeface="Google Sans Flex Medium"/>
+              </a:rPr>
+              <a:t>Snapshots of the prototype: Fix it</a:t>
+            </a:r>
+            <a:endParaRPr sz="1600">
+              <a:latin typeface="Google Sans Flex Medium"/>
+              <a:ea typeface="Google Sans Flex Medium"/>
+              <a:cs typeface="Google Sans Flex Medium"/>
+              <a:sym typeface="Google Sans Flex Medium"/>
+            </a:endParaRPr>
+          </a:p>
+        </p:txBody>
+      </p:sp>
+      <p:sp>
+        <p:nvSpPr>
+          <p:cNvPr id="136" name="Rectangle 135"/>
+          <p:cNvSpPr/>
+          <p:nvPr/>
+        </p:nvSpPr>
+        <p:spPr>
+          <a:xfrm>
+            <a:off x="431122" y="1289304"/>
+            <a:ext cx="2249578" cy="3380000"/>
+          </a:xfrm>
+          <a:prstGeom prst="rect">
+            <a:avLst/>
+          </a:prstGeom>
+          <a:solidFill>
+            <a:srgbClr val="111111"/>
+          </a:solidFill>
+          <a:ln>
+            <a:noFill/>
+          </a:ln>
+          <a:effectLst/>
+        </p:spPr>
+        <p:style>
+          <a:lnRef idx="1">
+            <a:schemeClr val="accent1"/>
+          </a:lnRef>
+          <a:fillRef idx="3">
+            <a:schemeClr val="accent1"/>
+          </a:fillRef>
+          <a:effectRef idx="2">
+            <a:schemeClr val="accent1"/>
+          </a:effectRef>
+          <a:fontRef idx="minor">
+            <a:schemeClr val="lt1"/>
+          </a:fontRef>
+        </p:style>
+        <p:txBody>
+          <a:bodyPr rtlCol="0" anchor="ctr"/>
+          <a:lstStyle/>
+          <a:p/>
+        </p:txBody>
+      </p:sp>
+      <p:pic>
+        <p:nvPicPr>
+          <p:cNvPr id="137" name="Picture 136" descr="Fix it: what each fix is worth, projected"/>
+          <p:cNvPicPr>
+            <a:picLocks noChangeAspect="1"/>
+          </p:cNvPicPr>
+          <p:nvPr/>
+        </p:nvPicPr>
+        <p:blipFill>
+          <a:blip r:embed="rId5"/>
+          <a:stretch>
+            <a:fillRect/>
+          </a:stretch>
+        </p:blipFill>
+        <p:spPr>
+          <a:xfrm>
+            <a:off x="385402" y="1243584"/>
+            <a:ext cx="2249578" cy="3380000"/>
+          </a:xfrm>
+          <a:prstGeom prst="rect">
+            <a:avLst/>
+          </a:prstGeom>
+          <a:ln w="19050">
+            <a:solidFill>
+              <a:srgbClr val="111111"/>
+            </a:solidFill>
+          </a:ln>
+        </p:spPr>
+      </p:pic>
+      <p:sp>
+        <p:nvSpPr>
+          <p:cNvPr id="138" name="Rounded Rectangle 137"/>
+          <p:cNvSpPr/>
+          <p:nvPr/>
+        </p:nvSpPr>
+        <p:spPr>
+          <a:xfrm>
+            <a:off x="312250" y="4393584"/>
+            <a:ext cx="2399578" cy="274320"/>
+          </a:xfrm>
+          <a:prstGeom prst="roundRect">
+            <a:avLst>
+              <a:gd name="adj" fmla="val 50000"/>
+            </a:avLst>
+          </a:prstGeom>
+          <a:solidFill>
+            <a:srgbClr val="C6F432"/>
+          </a:solidFill>
+          <a:ln w="15875">
+            <a:solidFill>
+              <a:srgbClr val="111111"/>
+            </a:solidFill>
+          </a:ln>
+          <a:effectLst/>
+        </p:spPr>
+        <p:style>
+          <a:lnRef idx="1">
+            <a:schemeClr val="accent1"/>
+          </a:lnRef>
+          <a:fillRef idx="3">
+            <a:schemeClr val="accent1"/>
+          </a:fillRef>
+          <a:effectRef idx="2">
+            <a:schemeClr val="accent1"/>
+          </a:effectRef>
+          <a:fontRef idx="minor">
+            <a:schemeClr val="lt1"/>
+          </a:fontRef>
+        </p:style>
+        <p:txBody>
+          <a:bodyPr rtlCol="0" anchor="ctr" lIns="54864" rIns="54864" tIns="0" bIns="0"/>
+          <a:lstStyle/>
+          <a:p>
+            <a:pPr algn="ctr"/>
+            <a:r>
+              <a:rPr sz="950" b="1">
+                <a:solidFill>
+                  <a:srgbClr val="111111"/>
+                </a:solidFill>
+                <a:latin typeface="Google Sans Flex"/>
+              </a:rPr>
+              <a:t>Fix it: what each fix is worth, projected</a:t>
+            </a:r>
+          </a:p>
+        </p:txBody>
+      </p:sp>
+      <p:sp>
+        <p:nvSpPr>
+          <p:cNvPr id="139" name="Rectangle 138"/>
+          <p:cNvSpPr/>
+          <p:nvPr/>
+        </p:nvSpPr>
+        <p:spPr>
+          <a:xfrm>
+            <a:off x="3010700" y="1289304"/>
+            <a:ext cx="5793020" cy="3223535"/>
+          </a:xfrm>
+          <a:prstGeom prst="rect">
+            <a:avLst/>
+          </a:prstGeom>
+          <a:solidFill>
+            <a:srgbClr val="111111"/>
+          </a:solidFill>
+          <a:ln>
+            <a:noFill/>
+          </a:ln>
+          <a:effectLst/>
+        </p:spPr>
+        <p:style>
+          <a:lnRef idx="1">
+            <a:schemeClr val="accent1"/>
+          </a:lnRef>
+          <a:fillRef idx="3">
+            <a:schemeClr val="accent1"/>
+          </a:fillRef>
+          <a:effectRef idx="2">
+            <a:schemeClr val="accent1"/>
+          </a:effectRef>
+          <a:fontRef idx="minor">
+            <a:schemeClr val="lt1"/>
+          </a:fontRef>
+        </p:style>
+        <p:txBody>
+          <a:bodyPr rtlCol="0" anchor="ctr"/>
+          <a:lstStyle/>
+          <a:p/>
+        </p:txBody>
+      </p:sp>
+      <p:pic>
+        <p:nvPicPr>
+          <p:cNvPr id="140" name="Picture 139" descr="Verified on a copy: 9 of 9 fixes verified, ₹1,894 → ₹1,596"/>
+          <p:cNvPicPr>
+            <a:picLocks noChangeAspect="1"/>
+          </p:cNvPicPr>
+          <p:nvPr/>
+        </p:nvPicPr>
+        <p:blipFill>
+          <a:blip r:embed="rId6"/>
+          <a:stretch>
+            <a:fillRect/>
+          </a:stretch>
+        </p:blipFill>
+        <p:spPr>
+          <a:xfrm>
+            <a:off x="2964980" y="1243584"/>
+            <a:ext cx="5793020" cy="3223535"/>
+          </a:xfrm>
+          <a:prstGeom prst="rect">
+            <a:avLst/>
+          </a:prstGeom>
+          <a:ln w="19050">
+            <a:solidFill>
+              <a:srgbClr val="111111"/>
+            </a:solidFill>
+          </a:ln>
+        </p:spPr>
+      </p:pic>
+      <p:sp>
+        <p:nvSpPr>
+          <p:cNvPr id="141" name="Rounded Rectangle 140"/>
+          <p:cNvSpPr/>
+          <p:nvPr/>
+        </p:nvSpPr>
+        <p:spPr>
+          <a:xfrm>
+            <a:off x="2891980" y="4327119"/>
+            <a:ext cx="3300000" cy="274320"/>
+          </a:xfrm>
+          <a:prstGeom prst="roundRect">
+            <a:avLst>
+              <a:gd name="adj" fmla="val 50000"/>
+            </a:avLst>
+          </a:prstGeom>
+          <a:solidFill>
+            <a:srgbClr val="FFD23F"/>
+          </a:solidFill>
+          <a:ln w="15875">
+            <a:solidFill>
+              <a:srgbClr val="111111"/>
+            </a:solidFill>
+          </a:ln>
+          <a:effectLst/>
+        </p:spPr>
+        <p:style>
+          <a:lnRef idx="1">
+            <a:schemeClr val="accent1"/>
+          </a:lnRef>
+          <a:fillRef idx="3">
+            <a:schemeClr val="accent1"/>
+          </a:fillRef>
+          <a:effectRef idx="2">
+            <a:schemeClr val="accent1"/>
+          </a:effectRef>
+          <a:fontRef idx="minor">
+            <a:schemeClr val="lt1"/>
+          </a:fontRef>
+        </p:style>
+        <p:txBody>
+          <a:bodyPr rtlCol="0" anchor="ctr" lIns="54864" rIns="54864" tIns="0" bIns="0"/>
+          <a:lstStyle/>
+          <a:p>
+            <a:pPr algn="ctr"/>
+            <a:r>
+              <a:rPr sz="950" b="1">
+                <a:solidFill>
+                  <a:srgbClr val="111111"/>
+                </a:solidFill>
+                <a:latin typeface="Google Sans Flex"/>
+              </a:rPr>
+              <a:t>Verified on a copy: 9 of 9 gone, ₹1,894 → ₹1,596</a:t>
+            </a:r>
+          </a:p>
+        </p:txBody>
+      </p:sp>
+    </p:spTree>
+  </p:cSld>
+  <p:clrMapOvr>
+    <a:masterClrMapping/>
+  </p:clrMapOvr>
+</p:sld>
+</file>
+
 <file path=ppt/slides/slide3.xml><?xml version="1.0" encoding="utf-8"?>
 <p:sld xmlns:a="http://schemas.openxmlformats.org/drawingml/2006/main" xmlns:r="http://schemas.openxmlformats.org/officeDocument/2006/relationships" xmlns:mc="http://schemas.openxmlformats.org/markup-compatibility/2006" xmlns:mv="urn:schemas-microsoft-com:mac:vml" xmlns:p="http://schemas.openxmlformats.org/presentationml/2006/main" xmlns:c="http://schemas.openxmlformats.org/drawingml/2006/chart" xmlns:dgm="http://schemas.openxmlformats.org/drawingml/2006/diagram" xmlns:o="urn:schemas-microsoft-com:office:office" xmlns:v="urn:schemas-microsoft-com:vml" xmlns:pvml="urn:schemas-microsoft-com:office:powerpoint" xmlns:com="http://schemas.openxmlformats.org/drawingml/2006/compatibility" xmlns:p14="http://schemas.microsoft.com/office/powerpoint/2010/main" xmlns:p15="http://schemas.microsoft.com/office/powerpoint/2012/main" xmlns:ahyp="http://schemas.microsoft.com/office/drawing/2018/hyperlinkcolor">
   <p:cSld>
@@ -18126,7 +18558,7 @@
                 </a:solidFill>
                 <a:latin typeface="Google Sans Flex"/>
               </a:rPr>
-              <a:t>3 months</a:t>
+              <a:t>26</a:t>
             </a:r>
           </a:p>
         </p:txBody>
@@ -18168,7 +18600,7 @@
                 </a:solidFill>
                 <a:latin typeface="Google Sans Flex"/>
               </a:rPr>
-              <a:t>for platforms to self-audit for them</a:t>
+              <a:t>platforms self-declared no dark patterns</a:t>
             </a:r>
           </a:p>
           <a:p>
@@ -18187,7 +18619,7 @@
                 </a:solidFill>
                 <a:latin typeface="Google Sans Flex"/>
               </a:rPr>
-              <a:t>CCPA advisory, June 2025</a:t>
+              <a:t>Nov 2025 · one, Zepto, was fined in Aug 2026</a:t>
             </a:r>
           </a:p>
         </p:txBody>
@@ -19876,7 +20308,7 @@
                 </a:solidFill>
                 <a:latin typeface="Google Sans Flex SemiBold"/>
               </a:rPr>
-              <a:t>A specific fix</a:t>
+              <a:t>A fix, then proof</a:t>
             </a:r>
           </a:p>
         </p:txBody>
@@ -20537,6 +20969,43 @@
               <a:t>against real price history in BigQuery.</a:t>
             </a:r>
           </a:p>
+          <a:p>
+            <a:pPr algn="l">
+              <a:lnSpc>
+                <a:spcPct val="105000"/>
+              </a:lnSpc>
+              <a:spcAft>
+                <a:spcPts val="1000"/>
+              </a:spcAft>
+            </a:pPr>
+            <a:r>
+              <a:rPr sz="850" b="0">
+                <a:solidFill>
+                  <a:srgbClr val="111111"/>
+                </a:solidFill>
+                <a:latin typeface="Google Sans Flex"/>
+              </a:rPr>
+              <a:t>■  </a:t>
+            </a:r>
+            <a:r>
+              <a:rPr sz="1050" b="1">
+                <a:solidFill>
+                  <a:srgbClr val="111111"/>
+                </a:solidFill>
+                <a:latin typeface="Google Sans Flex"/>
+              </a:rPr>
+              <a:t>Fixes, then proves it: </a:t>
+            </a:r>
+            <a:r>
+              <a:rPr sz="1050" b="0">
+                <a:solidFill>
+                  <a:srgbClr val="111111"/>
+                </a:solidFill>
+                <a:latin typeface="Google Sans Flex"/>
+              </a:rPr>
+              <a:t>applies each fix to a copy of the store and audits it again.</a:t>
+            </a:r>
+          </a:p>
         </p:txBody>
       </p:sp>
       <p:sp>
@@ -20935,7 +21404,7 @@
                 </a:solidFill>
                 <a:latin typeface="Google Sans Flex"/>
               </a:rPr>
-              <a:t>self-audit before the regulator does, as CCPA asked in June 2025.</a:t>
+              <a:t>a real self-audit, not a self-declaration: find, fix and prove it before the regulator does.</a:t>
             </a:r>
           </a:p>
           <a:p>
@@ -21484,7 +21953,7 @@
                 </a:solidFill>
                 <a:latin typeface="Google Sans Flex"/>
               </a:rPr>
-              <a:t>stops at sign-in walls and bot protection, and says what it couldn't see.</a:t>
+              <a:t>stops at sign-in walls and bot protection; a blocked page is "not checked", never "clean".</a:t>
             </a:r>
           </a:p>
         </p:txBody>
@@ -21634,7 +22103,7 @@
                 </a:solidFill>
                 <a:latin typeface="Google Sans Flex"/>
               </a:rPr>
-              <a:t> planted tricks caught  ·  </a:t>
+              <a:t> tricks caught  ·  </a:t>
             </a:r>
             <a:r>
               <a:rPr sz="1050" b="1">
@@ -21661,7 +22130,7 @@
                 </a:solidFill>
                 <a:latin typeface="Google Sans Flex"/>
               </a:rPr>
-              <a:t>0.962 F1</a:t>
+              <a:t>9/9</a:t>
             </a:r>
             <a:r>
               <a:rPr sz="1050" b="0">
@@ -21670,7 +22139,25 @@
                 </a:solidFill>
                 <a:latin typeface="Google Sans Flex"/>
               </a:rPr>
-              <a:t> zero-shot on 2,356 public shopping texts</a:t>
+              <a:t> fixes verified  ·  </a:t>
+            </a:r>
+            <a:r>
+              <a:rPr sz="1050" b="1">
+                <a:solidFill>
+                  <a:srgbClr val="111111"/>
+                </a:solidFill>
+                <a:latin typeface="Google Sans Flex"/>
+              </a:rPr>
+              <a:t>0.959 F1</a:t>
+            </a:r>
+            <a:r>
+              <a:rPr sz="1050" b="0">
+                <a:solidFill>
+                  <a:srgbClr val="111111"/>
+                </a:solidFill>
+                <a:latin typeface="Google Sans Flex"/>
+              </a:rPr>
+              <a:t> zero-shot on 2,356 public texts</a:t>
             </a:r>
           </a:p>
         </p:txBody>
@@ -22505,7 +22992,7 @@
                 </a:solidFill>
                 <a:latin typeface="Google Sans Flex"/>
               </a:rPr>
-              <a:t>Restarting timers, frozen stock, sneaked items, pre-ticked boxes, late fees.</a:t>
+              <a:t>Restarting timers, frozen stock, sneaked items, pre-ticked boxes, hidden fees.</a:t>
             </a:r>
           </a:p>
         </p:txBody>
@@ -23123,7 +23610,7 @@
                 </a:solidFill>
                 <a:latin typeface="Google Sans Flex"/>
               </a:rPr>
-              <a:t>Pattern Analyst</a:t>
+              <a:t>ADK agent graph</a:t>
             </a:r>
           </a:p>
         </p:txBody>
@@ -23165,7 +23652,7 @@
                 </a:solidFill>
                 <a:latin typeface="Google Sans Flex"/>
               </a:rPr>
-              <a:t>Gemini reads each screen for shaming, lopsided buttons and fake claims.</a:t>
+              <a:t>Gemini reads each screen; an Adjudicator agent checks the evidence with tools.</a:t>
             </a:r>
           </a:p>
         </p:txBody>
@@ -23352,7 +23839,7 @@
       </p:sp>
       <p:pic>
         <p:nvPicPr>
-          <p:cNvPr id="124" name="Picture 123" descr="l-scale-ink.png"/>
+          <p:cNvPr id="124" name="Picture 123" descr="l-wrench-ink.png"/>
           <p:cNvPicPr>
             <a:picLocks noChangeAspect="1"/>
           </p:cNvPicPr>
@@ -23453,7 +23940,7 @@
                 </a:solidFill>
                 <a:latin typeface="Google Sans Flex"/>
               </a:rPr>
-              <a:t>Adjudicator + review</a:t>
+              <a:t>Fix it + verify</a:t>
             </a:r>
           </a:p>
         </p:txBody>
@@ -23495,7 +23982,7 @@
                 </a:solidFill>
                 <a:latin typeface="Google Sans Flex"/>
               </a:rPr>
-              <a:t>A second Gemini check on the evidence; unsure claims go to a person.</a:t>
+              <a:t>A fix for each finding; watch the score move, then verify it on a copy.</a:t>
             </a:r>
           </a:p>
         </p:txBody>
@@ -24113,7 +24600,7 @@
                 </a:solidFill>
                 <a:latin typeface="Google Sans Flex"/>
               </a:rPr>
-              <a:t>Law &amp; fixes</a:t>
+              <a:t>Law + CCPA self-audit</a:t>
             </a:r>
           </a:p>
         </p:txBody>
@@ -24155,7 +24642,7 @@
                 </a:solidFill>
                 <a:latin typeface="Google Sans Flex"/>
               </a:rPr>
-              <a:t>The rule broken in India and 6 more regions, real penalties, one fix each.</a:t>
+              <a:t>The rule broken in India and 6 more regions; a 13-pattern CCPA self-audit PDF.</a:t>
             </a:r>
           </a:p>
         </p:txBody>
@@ -24485,7 +24972,7 @@
                 </a:solidFill>
                 <a:latin typeface="Google Sans Flex"/>
               </a:rPr>
-              <a:t>Trust score, PDF report; audits real stores logged out, replays for free.</a:t>
+              <a:t>Any public store, logged out; a blocked page says "not checked"; free replays.</a:t>
             </a:r>
           </a:p>
         </p:txBody>
@@ -27638,7 +28125,7 @@
                 </a:solidFill>
                 <a:latin typeface="Google Sans Flex"/>
               </a:rPr>
-              <a:t>Gemini re-checks a crop of it</a:t>
+              <a:t>re-checks it with tools</a:t>
             </a:r>
           </a:p>
         </p:txBody>
@@ -28039,7 +28526,7 @@
                 </a:solidFill>
                 <a:latin typeface="Google Sans Flex"/>
               </a:rPr>
-              <a:t>trust score  ·  the real bill  ·  legal exposure in 7 regions  ·  a fix for every finding  ·  PDF</a:t>
+              <a:t>trust score  ·  the real bill  ·  law in 7 regions  ·  CCPA self-audit  ·  PDF   →   Fix it: projected, then verified on a copy</a:t>
             </a:r>
           </a:p>
         </p:txBody>
@@ -28670,7 +29157,7 @@
                 </a:solidFill>
                 <a:latin typeface="Google Sans Flex"/>
               </a:rPr>
-              <a:t>Sample stores, or a real store like AutomationExercise or Flipkart.</a:t>
+              <a:t>Sample stores, or any public store, logged out.</a:t>
             </a:r>
           </a:p>
         </p:txBody>
@@ -29654,7 +30141,7 @@
                 </a:solidFill>
                 <a:latin typeface="Google Sans Flex"/>
               </a:rPr>
-              <a:t>Trust score, overcharge, fine risk, evidence and fixes. Download the PDF.</a:t>
+              <a:t>Trust score, the real bill, fine risk and evidence. Then Fix it and verify.</a:t>
             </a:r>
           </a:p>
         </p:txBody>
@@ -31010,7 +31497,7 @@
                 </a:solidFill>
                 <a:latin typeface="Google Sans Flex"/>
               </a:rPr>
-              <a:t>ADK agents</a:t>
+              <a:t>ADK agent graph</a:t>
             </a:r>
           </a:p>
           <a:p>
@@ -31029,7 +31516,7 @@
                 </a:solidFill>
                 <a:latin typeface="Google Sans Flex"/>
               </a:rPr>
-              <a:t>Pattern Analyst · Adjudicator</a:t>
+              <a:t>Analyst · Adjudicator (tools) · Fixer</a:t>
             </a:r>
           </a:p>
         </p:txBody>
@@ -31335,7 +31822,7 @@
                 </a:solidFill>
                 <a:latin typeface="Google Sans Flex"/>
               </a:rPr>
-              <a:t>3.8 Flash; 2.5 Flash as fallback</a:t>
+              <a:t>3.6 Flash; 3.1 Flash-Lite as fallback</a:t>
             </a:r>
           </a:p>
         </p:txBody>
@@ -31527,7 +32014,7 @@
                 </a:solidFill>
                 <a:latin typeface="Google Sans Flex"/>
               </a:rPr>
-              <a:t>The store</a:t>
+              <a:t>Any public store</a:t>
             </a:r>
           </a:p>
           <a:p>
@@ -31546,7 +32033,7 @@
                 </a:solidFill>
                 <a:latin typeface="Google Sans Flex"/>
               </a:rPr>
-              <a:t>allowlisted, logged out, SSRF guard</a:t>
+              <a:t>logged out · SSRF guard · or our demo stores</a:t>
             </a:r>
           </a:p>
         </p:txBody>
@@ -33289,7 +33776,7 @@
                 </a:solidFill>
                 <a:latin typeface="Google Sans Flex"/>
               </a:rPr>
-              <a:t>Gemini 3.8 Flash</a:t>
+              <a:t>Gemini 3.6 Flash</a:t>
             </a:r>
             <a:r>
               <a:rPr sz="800" b="0">
@@ -33463,7 +33950,7 @@
                 </a:solidFill>
                 <a:latin typeface="Google Sans Flex"/>
               </a:rPr>
-              <a:t>  agents + tools</a:t>
+              <a:t>  agent graph + tools</a:t>
             </a:r>
           </a:p>
         </p:txBody>

</xml_diff>

<commit_message>
docs: add Suvojit Konar to the team
</commit_message>
<xml_diff>
--- a/Zero Context - Shop Honest - AI Builder Cup.pptx
+++ b/Zero Context - Shop Honest - AI Builder Cup.pptx
@@ -1320,7 +1320,7 @@
           <a:lstStyle/>
           <a:p>
             <a:r>
-              <a:t>Team Zero Context (leader: Saubhagya Ashish). Shop Honest: AI agents shop an online store like a real customer and report every dark pattern with evidence, the rule it breaks, what it costs the shopper and a fix.</a:t>
+              <a:t>Team Zero Context: Saubhagya Ashish (leader) and Suvojit Konar. Shop Honest: AI agents shop an online store like a real customer and report every dark pattern with evidence, the rule it breaks, what it costs the shopper and a fix.</a:t>
             </a:r>
           </a:p>
         </p:txBody>
@@ -7358,6 +7358,31 @@
                 </a:solidFill>
                 <a:latin typeface="Google Sans Flex SemiBold"/>
               </a:rPr>
+              <a:t>Team member: </a:t>
+            </a:r>
+            <a:r>
+              <a:rPr sz="1300">
+                <a:solidFill>
+                  <a:srgbClr val="111111"/>
+                </a:solidFill>
+                <a:latin typeface="Google Sans Flex"/>
+              </a:rPr>
+              <a:t>Suvojit Konar</a:t>
+            </a:r>
+          </a:p>
+          <a:p>
+            <a:pPr>
+              <a:spcAft>
+                <a:spcPts val="500"/>
+              </a:spcAft>
+            </a:pPr>
+            <a:r>
+              <a:rPr sz="1300">
+                <a:solidFill>
+                  <a:srgbClr val="111111"/>
+                </a:solidFill>
+                <a:latin typeface="Google Sans Flex SemiBold"/>
+              </a:rPr>
               <a:t>Problem Statement: </a:t>
             </a:r>
             <a:r>

</xml_diff>

<commit_message>
docs(deck): the business pitch, fresh screenshots and the real platforms
A slide on the six self-declared platforms audited logged out (two carts with
fees sent for review, four blocked or out of stock, none called clean);
Responsible by design before Future, so Links is the last content slide;
slides 1-2 pitched to the store, the rigged test store labelled as such;
today's front page, report and a real pharmacy's report in the snapshots;
"Who pays" on Opportunities; the per-screen row named as the ADK agent
graph; a closing line, the site and the team on the thank-you slide; notes
for the Fix it and real-platforms slides. Production pre-flight re-run: 6/6.
</commit_message>
<xml_diff>
--- a/Zero Context - Shop Honest - AI Builder Cup.pptx
+++ b/Zero Context - Shop Honest - AI Builder Cup.pptx
@@ -20,9 +20,10 @@
     <p:sldId id="266" r:id="rId16"/>
     <p:sldId id="272" r:id="rId28"/>
     <p:sldId id="267" r:id="rId17"/>
+    <p:sldId id="273" r:id="rId29"/>
+    <p:sldId id="270" r:id="rId20"/>
     <p:sldId id="268" r:id="rId18"/>
     <p:sldId id="269" r:id="rId19"/>
-    <p:sldId id="270" r:id="rId20"/>
     <p:sldId id="271" r:id="rId21"/>
   </p:sldIdLst>
   <p:sldSz cy="5143500" cx="9144000"/>
@@ -1944,6 +1945,184 @@
           <a:p>
             <a:r>
               <a:t>Thank you. Try it at shop-honest-ai.web.app.</a:t>
+            </a:r>
+          </a:p>
+        </p:txBody>
+      </p:sp>
+    </p:spTree>
+  </p:cSld>
+  <p:clrMapOvr>
+    <a:masterClrMapping/>
+  </p:clrMapOvr>
+</p:notes>
+</file>
+
+<file path=ppt/notesSlides/notesSlide17.xml><?xml version="1.0" encoding="utf-8"?>
+<p:notes xmlns:a="http://schemas.openxmlformats.org/drawingml/2006/main" xmlns:r="http://schemas.openxmlformats.org/officeDocument/2006/relationships" xmlns:mc="http://schemas.openxmlformats.org/markup-compatibility/2006" xmlns:mv="urn:schemas-microsoft-com:mac:vml" xmlns:p="http://schemas.openxmlformats.org/presentationml/2006/main" xmlns:c="http://schemas.openxmlformats.org/drawingml/2006/chart" xmlns:dgm="http://schemas.openxmlformats.org/drawingml/2006/diagram" xmlns:o="urn:schemas-microsoft-com:office:office" xmlns:v="urn:schemas-microsoft-com:vml" xmlns:pvml="urn:schemas-microsoft-com:office:powerpoint" xmlns:com="http://schemas.openxmlformats.org/drawingml/2006/compatibility" xmlns:p14="http://schemas.microsoft.com/office/powerpoint/2010/main" xmlns:p15="http://schemas.microsoft.com/office/powerpoint/2012/main" xmlns:ahyp="http://schemas.microsoft.com/office/drawing/2018/hyperlinkcolor" showMasterPhAnim="0" showMasterSp="0">
+  <p:cSld>
+    <p:spTree>
+      <p:nvGrpSpPr>
+        <p:cNvPr id="136" name="Shape 136"/>
+        <p:cNvGrpSpPr/>
+        <p:nvPr/>
+      </p:nvGrpSpPr>
+      <p:grpSpPr>
+        <a:xfrm>
+          <a:off x="0" y="0"/>
+          <a:ext cx="0" cy="0"/>
+          <a:chOff x="0" y="0"/>
+          <a:chExt cx="0" cy="0"/>
+        </a:xfrm>
+      </p:grpSpPr>
+      <p:sp>
+        <p:nvSpPr>
+          <p:cNvPr id="137" name="Google Shape;137;g3fb085bff3c_0_51:notes"/>
+          <p:cNvSpPr/>
+          <p:nvPr>
+            <p:ph idx="2" type="sldImg"/>
+          </p:nvPr>
+        </p:nvSpPr>
+        <p:spPr>
+          <a:xfrm>
+            <a:off x="381300" y="685800"/>
+            <a:ext cx="6096000" cy="3429000"/>
+          </a:xfrm>
+          <a:custGeom>
+            <a:rect b="b" l="l" r="r" t="t"/>
+            <a:pathLst>
+              <a:path extrusionOk="0" h="120000" w="120000">
+                <a:moveTo>
+                  <a:pt x="0" y="0"/>
+                </a:moveTo>
+                <a:lnTo>
+                  <a:pt x="120000" y="0"/>
+                </a:lnTo>
+                <a:lnTo>
+                  <a:pt x="120000" y="120000"/>
+                </a:lnTo>
+                <a:lnTo>
+                  <a:pt x="0" y="120000"/>
+                </a:lnTo>
+                <a:close/>
+              </a:path>
+            </a:pathLst>
+          </a:custGeom>
+        </p:spPr>
+      </p:sp>
+      <p:sp>
+        <p:nvSpPr>
+          <p:cNvPr id="138" name="Google Shape;138;g3fb085bff3c_0_51:notes"/>
+          <p:cNvSpPr txBox="1"/>
+          <p:nvPr>
+            <p:ph idx="1" type="body"/>
+          </p:nvPr>
+        </p:nvSpPr>
+        <p:spPr>
+          <a:xfrm>
+            <a:off x="685800" y="4343400"/>
+            <a:ext cx="5486400" cy="4114800"/>
+          </a:xfrm>
+          <a:prstGeom prst="rect">
+            <a:avLst/>
+          </a:prstGeom>
+        </p:spPr>
+        <p:txBody>
+          <a:bodyPr anchorCtr="0" anchor="t" bIns="91425" lIns="91425" spcFirstLastPara="1" rIns="91425" wrap="square" tIns="91425">
+            <a:noAutofit/>
+          </a:bodyPr>
+          <a:lstStyle/>
+          <a:p>
+            <a:r>
+              <a:t>Fix it, on the finished report. The Fixer proposes a fix for each finding as a change to the store's own settings, each checked against the kinds of dark pattern that setting can fix. Switching fixes on moves the projected numbers: trust score, hidden extras, the fine ceiling and the CCPA patterns found. Verify then applies them to a copy of the store in the auditor's own browser and audits the copy live: on Gemini, 9 of 9 fixes verified, trust score 16 → 100, the shopper pays ₹1,596 instead of ₹1,894. Real sites are never changed; their developers get the fix list and a re-audit.</a:t>
+            </a:r>
+          </a:p>
+        </p:txBody>
+      </p:sp>
+    </p:spTree>
+  </p:cSld>
+  <p:clrMapOvr>
+    <a:masterClrMapping/>
+  </p:clrMapOvr>
+</p:notes>
+</file>
+
+<file path=ppt/notesSlides/notesSlide18.xml><?xml version="1.0" encoding="utf-8"?>
+<p:notes xmlns:a="http://schemas.openxmlformats.org/drawingml/2006/main" xmlns:r="http://schemas.openxmlformats.org/officeDocument/2006/relationships" xmlns:mc="http://schemas.openxmlformats.org/markup-compatibility/2006" xmlns:mv="urn:schemas-microsoft-com:mac:vml" xmlns:p="http://schemas.openxmlformats.org/presentationml/2006/main" xmlns:c="http://schemas.openxmlformats.org/drawingml/2006/chart" xmlns:dgm="http://schemas.openxmlformats.org/drawingml/2006/diagram" xmlns:o="urn:schemas-microsoft-com:office:office" xmlns:v="urn:schemas-microsoft-com:vml" xmlns:pvml="urn:schemas-microsoft-com:office:powerpoint" xmlns:com="http://schemas.openxmlformats.org/drawingml/2006/compatibility" xmlns:p14="http://schemas.microsoft.com/office/powerpoint/2010/main" xmlns:p15="http://schemas.microsoft.com/office/powerpoint/2012/main" xmlns:ahyp="http://schemas.microsoft.com/office/drawing/2018/hyperlinkcolor" showMasterPhAnim="0" showMasterSp="0">
+  <p:cSld>
+    <p:spTree>
+      <p:nvGrpSpPr>
+        <p:cNvPr id="136" name="Shape 136"/>
+        <p:cNvGrpSpPr/>
+        <p:nvPr/>
+      </p:nvGrpSpPr>
+      <p:grpSpPr>
+        <a:xfrm>
+          <a:off x="0" y="0"/>
+          <a:ext cx="0" cy="0"/>
+          <a:chOff x="0" y="0"/>
+          <a:chExt cx="0" cy="0"/>
+        </a:xfrm>
+      </p:grpSpPr>
+      <p:sp>
+        <p:nvSpPr>
+          <p:cNvPr id="137" name="Google Shape;137;g3fb085bff3c_0_51:notes"/>
+          <p:cNvSpPr/>
+          <p:nvPr>
+            <p:ph idx="2" type="sldImg"/>
+          </p:nvPr>
+        </p:nvSpPr>
+        <p:spPr>
+          <a:xfrm>
+            <a:off x="381300" y="685800"/>
+            <a:ext cx="6096000" cy="3429000"/>
+          </a:xfrm>
+          <a:custGeom>
+            <a:rect b="b" l="l" r="r" t="t"/>
+            <a:pathLst>
+              <a:path extrusionOk="0" h="120000" w="120000">
+                <a:moveTo>
+                  <a:pt x="0" y="0"/>
+                </a:moveTo>
+                <a:lnTo>
+                  <a:pt x="120000" y="0"/>
+                </a:lnTo>
+                <a:lnTo>
+                  <a:pt x="120000" y="120000"/>
+                </a:lnTo>
+                <a:lnTo>
+                  <a:pt x="0" y="120000"/>
+                </a:lnTo>
+                <a:close/>
+              </a:path>
+            </a:pathLst>
+          </a:custGeom>
+        </p:spPr>
+      </p:sp>
+      <p:sp>
+        <p:nvSpPr>
+          <p:cNvPr id="138" name="Google Shape;138;g3fb085bff3c_0_51:notes"/>
+          <p:cNvSpPr txBox="1"/>
+          <p:nvPr>
+            <p:ph idx="1" type="body"/>
+          </p:nvPr>
+        </p:nvSpPr>
+        <p:spPr>
+          <a:xfrm>
+            <a:off x="685800" y="4343400"/>
+            <a:ext cx="5486400" cy="4114800"/>
+          </a:xfrm>
+          <a:prstGeom prst="rect">
+            <a:avLst/>
+          </a:prstGeom>
+        </p:spPr>
+        <p:txBody>
+          <a:bodyPr anchorCtr="0" anchor="t" bIns="91425" lIns="91425" spcFirstLastPara="1" rIns="91425" wrap="square" tIns="91425">
+            <a:noAutofit/>
+          </a:bodyPr>
+          <a:lstStyle/>
+          <a:p>
+            <a:r>
+              <a:t>Six of the 26 platforms that declared themselves free of dark patterns in November 2025, audited logged out on 16 October 2026. Tata 1mg and Flipkart reached the cart, and each fee the product page didn't show was sent for human review, not asserted. Blinkit's product was out of stock. Zepto, which the CCPA fined in August 2026, served our browser an empty page; Myntra refused the connection; Meesho's bot protection stopped the agent. None was called clean. The lesson: outside audits get blocked, and the tricks the CCPA fined sit behind sign-in, so the audit belongs on the platform's side, before release.</a:t>
             </a:r>
           </a:p>
         </p:txBody>
@@ -7392,7 +7571,7 @@
                 </a:solidFill>
                 <a:latin typeface="Google Sans Flex"/>
               </a:rPr>
-              <a:t>Retail &amp; Commerce. Online stores use dark patterns (fake countdowns, items sneaked into the cart, fees revealed only at payment) that make shoppers pay more than they agreed to. India's CCPA bans 13 such patterns, yet nobody audits the whole journey the way a shopper experiences it.</a:t>
+              <a:t>Retail &amp; Commerce. Online stores use dark patterns (fake countdowns, items sneaked into the cart, fees revealed only at payment). India's CCPA bans 13 of them and fines platforms that use them. 26 platforms self-declared compliance, yet nobody audits the whole journey the way a shopper meets it.</a:t>
             </a:r>
           </a:p>
         </p:txBody>
@@ -7669,7 +7848,7 @@
                 </a:solidFill>
                 <a:latin typeface="Google Sans Flex"/>
               </a:rPr>
-              <a:t>AI agents that shop like you</a:t>
+              <a:t>Found, fixed and proven</a:t>
             </a:r>
           </a:p>
         </p:txBody>
@@ -10701,7 +10880,7 @@
                 </a:solidFill>
                 <a:latin typeface="Google Sans Flex"/>
               </a:rPr>
-              <a:t>Verdict: trust score, overcharge, fine risk</a:t>
+              <a:t>Verdict: trust score, overcharge, fine risk, Fix it</a:t>
             </a:r>
           </a:p>
         </p:txBody>
@@ -11006,7 +11185,7 @@
       </p:sp>
       <p:pic>
         <p:nvPicPr>
-          <p:cNvPr id="146" name="Picture 145" descr="A real store, logged out: stops at sign-in"/>
+          <p:cNvPr id="146" name="Picture 145" descr="A real pharmacy, logged out: 2 claims for review"/>
           <p:cNvPicPr>
             <a:picLocks noChangeAspect="1"/>
           </p:cNvPicPr>
@@ -11085,7 +11264,7 @@
                 </a:solidFill>
                 <a:latin typeface="Google Sans Flex"/>
               </a:rPr>
-              <a:t>A real store, logged out: stops at sign-in</a:t>
+              <a:t>A real pharmacy: 2 claims for review</a:t>
             </a:r>
           </a:p>
         </p:txBody>
@@ -17430,6 +17609,77 @@
           </a:ln>
         </p:spPr>
       </p:pic>
+      <p:sp>
+        <p:nvSpPr>
+          <p:cNvPr id="300" name="Closing line"/>
+          <p:cNvSpPr txBox="1"/>
+          <p:nvPr/>
+        </p:nvSpPr>
+        <p:spPr>
+          <a:xfrm>
+            <a:off x="4754880" y="2148840"/>
+            <a:ext cx="4114800" cy="777240"/>
+          </a:xfrm>
+          <a:prstGeom prst="rect">
+            <a:avLst/>
+          </a:prstGeom>
+          <a:noFill/>
+        </p:spPr>
+        <p:txBody>
+          <a:bodyPr wrap="square" lIns="0" tIns="0" rIns="0" bIns="0">
+            <a:noAutofit/>
+          </a:bodyPr>
+          <a:lstStyle/>
+          <a:p>
+            <a:pPr algn="l">
+              <a:spcAft>
+                <a:spcPts val="600"/>
+              </a:spcAft>
+            </a:pPr>
+            <a:r>
+              <a:rPr sz="1300" b="1">
+                <a:solidFill>
+                  <a:srgbClr val="C6F432"/>
+                </a:solidFill>
+                <a:latin typeface="Google Sans Flex"/>
+              </a:rPr>
+              <a:t>Found, fixed and proven, before it costs you a CCPA fine.</a:t>
+            </a:r>
+          </a:p>
+          <a:p>
+            <a:pPr algn="l">
+              <a:spcAft>
+                <a:spcPts val="600"/>
+              </a:spcAft>
+            </a:pPr>
+            <a:r>
+              <a:rPr sz="1150" b="1">
+                <a:solidFill>
+                  <a:srgbClr val="FFFFFF"/>
+                </a:solidFill>
+                <a:latin typeface="Google Sans Flex"/>
+              </a:rPr>
+              <a:t>shop-honest-ai.web.app</a:t>
+            </a:r>
+          </a:p>
+          <a:p>
+            <a:pPr algn="l">
+              <a:spcAft>
+                <a:spcPts val="0"/>
+              </a:spcAft>
+            </a:pPr>
+            <a:r>
+              <a:rPr sz="1050" b="0">
+                <a:solidFill>
+                  <a:srgbClr val="D9D9D9"/>
+                </a:solidFill>
+                <a:latin typeface="Google Sans Flex"/>
+              </a:rPr>
+              <a:t>Team Zero Context · Saubhagya Ashish · Suvojit Konar</a:t>
+            </a:r>
+          </a:p>
+        </p:txBody>
+      </p:sp>
     </p:spTree>
   </p:cSld>
   <p:clrMapOvr>
@@ -17869,6 +18119,2293 @@
 </p:sld>
 </file>
 
+<file path=ppt/slides/slide18.xml><?xml version="1.0" encoding="utf-8"?>
+<p:sld xmlns:a="http://schemas.openxmlformats.org/drawingml/2006/main" xmlns:r="http://schemas.openxmlformats.org/officeDocument/2006/relationships" xmlns:mc="http://schemas.openxmlformats.org/markup-compatibility/2006" xmlns:mv="urn:schemas-microsoft-com:mac:vml" xmlns:p="http://schemas.openxmlformats.org/presentationml/2006/main" xmlns:c="http://schemas.openxmlformats.org/drawingml/2006/chart" xmlns:dgm="http://schemas.openxmlformats.org/drawingml/2006/diagram" xmlns:o="urn:schemas-microsoft-com:office:office" xmlns:v="urn:schemas-microsoft-com:vml" xmlns:pvml="urn:schemas-microsoft-com:office:powerpoint" xmlns:com="http://schemas.openxmlformats.org/drawingml/2006/compatibility" xmlns:p14="http://schemas.microsoft.com/office/powerpoint/2010/main" xmlns:p15="http://schemas.microsoft.com/office/powerpoint/2012/main" xmlns:ahyp="http://schemas.microsoft.com/office/drawing/2018/hyperlinkcolor">
+  <p:cSld>
+    <p:spTree>
+      <p:nvGrpSpPr>
+        <p:cNvPr id="147" name="Shape 147"/>
+        <p:cNvGrpSpPr/>
+        <p:nvPr/>
+      </p:nvGrpSpPr>
+      <p:grpSpPr>
+        <a:xfrm>
+          <a:off x="0" y="0"/>
+          <a:ext cx="0" cy="0"/>
+          <a:chOff x="0" y="0"/>
+          <a:chExt cx="0" cy="0"/>
+        </a:xfrm>
+      </p:grpSpPr>
+      <p:pic>
+        <p:nvPicPr>
+          <p:cNvPr id="148" name="Google Shape;148;p25" title="Frame 144.png"/>
+          <p:cNvPicPr preferRelativeResize="0"/>
+          <p:nvPr/>
+        </p:nvPicPr>
+        <p:blipFill rotWithShape="1">
+          <a:blip r:embed="rId3">
+            <a:alphaModFix/>
+          </a:blip>
+          <a:srcRect b="98001" l="0" r="0" t="0"/>
+          <a:stretch/>
+        </p:blipFill>
+        <p:spPr>
+          <a:xfrm>
+            <a:off x="0" y="5093562"/>
+            <a:ext cx="9144000" cy="54275"/>
+          </a:xfrm>
+          <a:prstGeom prst="rect">
+            <a:avLst/>
+          </a:prstGeom>
+          <a:noFill/>
+          <a:ln>
+            <a:noFill/>
+          </a:ln>
+        </p:spPr>
+      </p:pic>
+      <p:pic>
+        <p:nvPicPr>
+          <p:cNvPr id="149" name="Google Shape;149;p25" title="Group 427319979.png"/>
+          <p:cNvPicPr preferRelativeResize="0"/>
+          <p:nvPr/>
+        </p:nvPicPr>
+        <p:blipFill>
+          <a:blip r:embed="rId4">
+            <a:alphaModFix/>
+          </a:blip>
+          <a:stretch>
+            <a:fillRect/>
+          </a:stretch>
+        </p:blipFill>
+        <p:spPr>
+          <a:xfrm>
+            <a:off x="0" y="1"/>
+            <a:ext cx="9144000" cy="507359"/>
+          </a:xfrm>
+          <a:prstGeom prst="rect">
+            <a:avLst/>
+          </a:prstGeom>
+          <a:noFill/>
+          <a:ln>
+            <a:noFill/>
+          </a:ln>
+        </p:spPr>
+      </p:pic>
+      <p:sp>
+        <p:nvSpPr>
+          <p:cNvPr id="150" name="Google Shape;150;p25"/>
+          <p:cNvSpPr/>
+          <p:nvPr/>
+        </p:nvSpPr>
+        <p:spPr>
+          <a:xfrm>
+            <a:off x="-29250" y="5071875"/>
+            <a:ext cx="9173400" cy="97800"/>
+          </a:xfrm>
+          <a:prstGeom prst="rect">
+            <a:avLst/>
+          </a:prstGeom>
+          <a:solidFill>
+            <a:schemeClr val="dk1"/>
+          </a:solidFill>
+          <a:ln>
+            <a:noFill/>
+          </a:ln>
+        </p:spPr>
+        <p:txBody>
+          <a:bodyPr anchorCtr="0" anchor="ctr" bIns="91425" lIns="91425" spcFirstLastPara="1" rIns="91425" wrap="square" tIns="91425">
+            <a:noAutofit/>
+          </a:bodyPr>
+          <a:lstStyle/>
+          <a:p>
+            <a:pPr indent="0" lvl="0" marL="0" rtl="0" algn="ctr">
+              <a:spcBef>
+                <a:spcPts val="0"/>
+              </a:spcBef>
+              <a:spcAft>
+                <a:spcPts val="0"/>
+              </a:spcAft>
+              <a:buNone/>
+            </a:pPr>
+            <a:r>
+              <a:t/>
+            </a:r>
+            <a:endParaRPr/>
+          </a:p>
+        </p:txBody>
+      </p:sp>
+      <p:sp>
+        <p:nvSpPr>
+          <p:cNvPr id="151" name="Google Shape;151;p25"/>
+          <p:cNvSpPr txBox="1"/>
+          <p:nvPr/>
+        </p:nvSpPr>
+        <p:spPr>
+          <a:xfrm>
+            <a:off x="265350" y="663825"/>
+            <a:ext cx="8943000" cy="561900"/>
+          </a:xfrm>
+          <a:prstGeom prst="rect">
+            <a:avLst/>
+          </a:prstGeom>
+          <a:noFill/>
+          <a:ln>
+            <a:noFill/>
+          </a:ln>
+        </p:spPr>
+        <p:txBody>
+          <a:bodyPr anchorCtr="0" anchor="t" bIns="91425" lIns="91425" spcFirstLastPara="1" rIns="91425" wrap="square" tIns="91425">
+            <a:noAutofit/>
+          </a:bodyPr>
+          <a:lstStyle/>
+          <a:p>
+            <a:pPr indent="0" lvl="0" marL="0" rtl="0" algn="l">
+              <a:spcBef>
+                <a:spcPts val="0"/>
+              </a:spcBef>
+              <a:spcAft>
+                <a:spcPts val="0"/>
+              </a:spcAft>
+              <a:buNone/>
+            </a:pPr>
+            <a:r>
+              <a:rPr lang="en-GB" sz="1600">
+                <a:latin typeface="Google Sans Flex Medium"/>
+                <a:ea typeface="Google Sans Flex Medium"/>
+                <a:cs typeface="Google Sans Flex Medium"/>
+                <a:sym typeface="Google Sans Flex Medium"/>
+              </a:rPr>
+              <a:t>Tested on the real platforms: 6 of the 26 self-declared</a:t>
+            </a:r>
+            <a:endParaRPr sz="1600">
+              <a:latin typeface="Google Sans Flex Medium"/>
+              <a:ea typeface="Google Sans Flex Medium"/>
+              <a:cs typeface="Google Sans Flex Medium"/>
+              <a:sym typeface="Google Sans Flex Medium"/>
+            </a:endParaRPr>
+          </a:p>
+        </p:txBody>
+      </p:sp>
+      <p:sp>
+        <p:nvSpPr>
+          <p:cNvPr id="152" name="Rounded Rectangle 151"/>
+          <p:cNvSpPr/>
+          <p:nvPr/>
+        </p:nvSpPr>
+        <p:spPr>
+          <a:xfrm>
+            <a:off x="365759" y="1325880"/>
+            <a:ext cx="2724912" cy="1664208"/>
+          </a:xfrm>
+          <a:prstGeom prst="roundRect">
+            <a:avLst>
+              <a:gd name="adj" fmla="val 6593"/>
+            </a:avLst>
+          </a:prstGeom>
+          <a:solidFill>
+            <a:srgbClr val="111111"/>
+          </a:solidFill>
+          <a:ln>
+            <a:noFill/>
+          </a:ln>
+          <a:effectLst/>
+        </p:spPr>
+        <p:style>
+          <a:lnRef idx="1">
+            <a:schemeClr val="accent1"/>
+          </a:lnRef>
+          <a:fillRef idx="3">
+            <a:schemeClr val="accent1"/>
+          </a:fillRef>
+          <a:effectRef idx="2">
+            <a:schemeClr val="accent1"/>
+          </a:effectRef>
+          <a:fontRef idx="minor">
+            <a:schemeClr val="lt1"/>
+          </a:fontRef>
+        </p:style>
+        <p:txBody>
+          <a:bodyPr rtlCol="0" anchor="ctr"/>
+          <a:lstStyle/>
+          <a:p/>
+        </p:txBody>
+      </p:sp>
+      <p:sp>
+        <p:nvSpPr>
+          <p:cNvPr id="153" name="Rounded Rectangle 152"/>
+          <p:cNvSpPr/>
+          <p:nvPr/>
+        </p:nvSpPr>
+        <p:spPr>
+          <a:xfrm>
+            <a:off x="320040" y="1280160"/>
+            <a:ext cx="2724912" cy="1664208"/>
+          </a:xfrm>
+          <a:prstGeom prst="roundRect">
+            <a:avLst>
+              <a:gd name="adj" fmla="val 6593"/>
+            </a:avLst>
+          </a:prstGeom>
+          <a:solidFill>
+            <a:srgbClr val="FFFFFF"/>
+          </a:solidFill>
+          <a:ln w="19050">
+            <a:solidFill>
+              <a:srgbClr val="111111"/>
+            </a:solidFill>
+          </a:ln>
+          <a:effectLst/>
+        </p:spPr>
+        <p:style>
+          <a:lnRef idx="1">
+            <a:schemeClr val="accent1"/>
+          </a:lnRef>
+          <a:fillRef idx="3">
+            <a:schemeClr val="accent1"/>
+          </a:fillRef>
+          <a:effectRef idx="2">
+            <a:schemeClr val="accent1"/>
+          </a:effectRef>
+          <a:fontRef idx="minor">
+            <a:schemeClr val="lt1"/>
+          </a:fontRef>
+        </p:style>
+        <p:txBody>
+          <a:bodyPr rtlCol="0" anchor="ctr"/>
+          <a:lstStyle/>
+          <a:p/>
+        </p:txBody>
+      </p:sp>
+      <p:sp>
+        <p:nvSpPr>
+          <p:cNvPr id="154" name="Rounded Rectangle 153"/>
+          <p:cNvSpPr/>
+          <p:nvPr/>
+        </p:nvSpPr>
+        <p:spPr>
+          <a:xfrm>
+            <a:off x="493776" y="1463039"/>
+            <a:ext cx="475488" cy="475488"/>
+          </a:xfrm>
+          <a:prstGeom prst="roundRect">
+            <a:avLst>
+              <a:gd name="adj" fmla="val 24000"/>
+            </a:avLst>
+          </a:prstGeom>
+          <a:solidFill>
+            <a:srgbClr val="111111"/>
+          </a:solidFill>
+          <a:ln>
+            <a:noFill/>
+          </a:ln>
+          <a:effectLst/>
+        </p:spPr>
+        <p:style>
+          <a:lnRef idx="1">
+            <a:schemeClr val="accent1"/>
+          </a:lnRef>
+          <a:fillRef idx="3">
+            <a:schemeClr val="accent1"/>
+          </a:fillRef>
+          <a:effectRef idx="2">
+            <a:schemeClr val="accent1"/>
+          </a:effectRef>
+          <a:fontRef idx="minor">
+            <a:schemeClr val="lt1"/>
+          </a:fontRef>
+        </p:style>
+        <p:txBody>
+          <a:bodyPr rtlCol="0" anchor="ctr"/>
+          <a:lstStyle/>
+          <a:p/>
+        </p:txBody>
+      </p:sp>
+      <p:sp>
+        <p:nvSpPr>
+          <p:cNvPr id="155" name="Rounded Rectangle 154"/>
+          <p:cNvSpPr/>
+          <p:nvPr/>
+        </p:nvSpPr>
+        <p:spPr>
+          <a:xfrm>
+            <a:off x="466344" y="1435607"/>
+            <a:ext cx="475488" cy="475488"/>
+          </a:xfrm>
+          <a:prstGeom prst="roundRect">
+            <a:avLst>
+              <a:gd name="adj" fmla="val 24000"/>
+            </a:avLst>
+          </a:prstGeom>
+          <a:solidFill>
+            <a:srgbClr val="C6F432"/>
+          </a:solidFill>
+          <a:ln w="15875">
+            <a:solidFill>
+              <a:srgbClr val="111111"/>
+            </a:solidFill>
+          </a:ln>
+          <a:effectLst/>
+        </p:spPr>
+        <p:style>
+          <a:lnRef idx="1">
+            <a:schemeClr val="accent1"/>
+          </a:lnRef>
+          <a:fillRef idx="3">
+            <a:schemeClr val="accent1"/>
+          </a:fillRef>
+          <a:effectRef idx="2">
+            <a:schemeClr val="accent1"/>
+          </a:effectRef>
+          <a:fontRef idx="minor">
+            <a:schemeClr val="lt1"/>
+          </a:fontRef>
+        </p:style>
+        <p:txBody>
+          <a:bodyPr rtlCol="0" anchor="ctr"/>
+          <a:lstStyle/>
+          <a:p/>
+        </p:txBody>
+      </p:sp>
+      <p:pic>
+        <p:nvPicPr>
+          <p:cNvPr id="156" name="Picture 155" descr="l-list-checks-ink.png"/>
+          <p:cNvPicPr>
+            <a:picLocks noChangeAspect="1"/>
+          </p:cNvPicPr>
+          <p:nvPr/>
+        </p:nvPicPr>
+        <p:blipFill>
+          <a:blip r:embed="rId5"/>
+          <a:stretch>
+            <a:fillRect/>
+          </a:stretch>
+        </p:blipFill>
+        <p:spPr>
+          <a:xfrm>
+            <a:off x="561441" y="1530705"/>
+            <a:ext cx="285292" cy="285292"/>
+          </a:xfrm>
+          <a:prstGeom prst="rect">
+            <a:avLst/>
+          </a:prstGeom>
+        </p:spPr>
+      </p:pic>
+      <p:sp>
+        <p:nvSpPr>
+          <p:cNvPr id="157" name="Rounded Rectangle 156"/>
+          <p:cNvSpPr/>
+          <p:nvPr/>
+        </p:nvSpPr>
+        <p:spPr>
+          <a:xfrm>
+            <a:off x="2071720" y="1463039"/>
+            <a:ext cx="826928" cy="219456"/>
+          </a:xfrm>
+          <a:prstGeom prst="roundRect">
+            <a:avLst>
+              <a:gd name="adj" fmla="val 50000"/>
+            </a:avLst>
+          </a:prstGeom>
+          <a:solidFill>
+            <a:srgbClr val="111111"/>
+          </a:solidFill>
+          <a:ln w="15875">
+            <a:solidFill>
+              <a:srgbClr val="111111"/>
+            </a:solidFill>
+          </a:ln>
+          <a:effectLst/>
+        </p:spPr>
+        <p:style>
+          <a:lnRef idx="1">
+            <a:schemeClr val="accent1"/>
+          </a:lnRef>
+          <a:fillRef idx="3">
+            <a:schemeClr val="accent1"/>
+          </a:fillRef>
+          <a:effectRef idx="2">
+            <a:schemeClr val="accent1"/>
+          </a:effectRef>
+          <a:fontRef idx="minor">
+            <a:schemeClr val="lt1"/>
+          </a:fontRef>
+        </p:style>
+        <p:txBody>
+          <a:bodyPr rtlCol="0" anchor="ctr" lIns="54864" rIns="54864" tIns="0" bIns="0"/>
+          <a:lstStyle/>
+          <a:p>
+            <a:pPr algn="ctr"/>
+            <a:r>
+              <a:rPr sz="800" b="1">
+                <a:solidFill>
+                  <a:srgbClr val="FFFFFF"/>
+                </a:solidFill>
+                <a:latin typeface="Google Sans Flex"/>
+              </a:rPr>
+              <a:t>CART</a:t>
+            </a:r>
+          </a:p>
+        </p:txBody>
+      </p:sp>
+      <p:sp>
+        <p:nvSpPr>
+          <p:cNvPr id="158" name="TextBox 157"/>
+          <p:cNvSpPr txBox="1"/>
+          <p:nvPr/>
+        </p:nvSpPr>
+        <p:spPr>
+          <a:xfrm>
+            <a:off x="466344" y="2029967"/>
+            <a:ext cx="2450592" cy="274320"/>
+          </a:xfrm>
+          <a:prstGeom prst="rect">
+            <a:avLst/>
+          </a:prstGeom>
+          <a:noFill/>
+        </p:spPr>
+        <p:txBody>
+          <a:bodyPr wrap="square" lIns="0" rIns="0" tIns="0" bIns="0" anchor="t">
+            <a:noAutofit/>
+          </a:bodyPr>
+          <a:lstStyle/>
+          <a:p>
+            <a:pPr algn="l">
+              <a:lnSpc>
+                <a:spcPct val="100000"/>
+              </a:lnSpc>
+              <a:spcAft>
+                <a:spcPts val="0"/>
+              </a:spcAft>
+            </a:pPr>
+            <a:r>
+              <a:rPr sz="1200" b="1">
+                <a:solidFill>
+                  <a:srgbClr val="111111"/>
+                </a:solidFill>
+                <a:latin typeface="Google Sans Flex"/>
+              </a:rPr>
+              <a:t>Tata 1mg</a:t>
+            </a:r>
+          </a:p>
+        </p:txBody>
+      </p:sp>
+      <p:sp>
+        <p:nvSpPr>
+          <p:cNvPr id="159" name="TextBox 158"/>
+          <p:cNvSpPr txBox="1"/>
+          <p:nvPr/>
+        </p:nvSpPr>
+        <p:spPr>
+          <a:xfrm>
+            <a:off x="466344" y="2322576"/>
+            <a:ext cx="2450592" cy="594360"/>
+          </a:xfrm>
+          <a:prstGeom prst="rect">
+            <a:avLst/>
+          </a:prstGeom>
+          <a:noFill/>
+        </p:spPr>
+        <p:txBody>
+          <a:bodyPr wrap="square" lIns="0" rIns="0" tIns="0" bIns="0" anchor="t">
+            <a:noAutofit/>
+          </a:bodyPr>
+          <a:lstStyle/>
+          <a:p>
+            <a:pPr algn="l">
+              <a:lnSpc>
+                <a:spcPct val="105000"/>
+              </a:lnSpc>
+              <a:spcAft>
+                <a:spcPts val="0"/>
+              </a:spcAft>
+            </a:pPr>
+            <a:r>
+              <a:rPr sz="950" b="0">
+                <a:solidFill>
+                  <a:srgbClr val="3C4043"/>
+                </a:solidFill>
+                <a:latin typeface="Google Sans Flex"/>
+              </a:rPr>
+              <a:t>Reached the cart, then its sign-in popup. A ₹12 handling charge first shown in the cart: sent for review.</a:t>
+            </a:r>
+          </a:p>
+        </p:txBody>
+      </p:sp>
+      <p:sp>
+        <p:nvSpPr>
+          <p:cNvPr id="160" name="Rounded Rectangle 159"/>
+          <p:cNvSpPr/>
+          <p:nvPr/>
+        </p:nvSpPr>
+        <p:spPr>
+          <a:xfrm>
+            <a:off x="3255264" y="1325880"/>
+            <a:ext cx="2724912" cy="1664208"/>
+          </a:xfrm>
+          <a:prstGeom prst="roundRect">
+            <a:avLst>
+              <a:gd name="adj" fmla="val 6593"/>
+            </a:avLst>
+          </a:prstGeom>
+          <a:solidFill>
+            <a:srgbClr val="111111"/>
+          </a:solidFill>
+          <a:ln>
+            <a:noFill/>
+          </a:ln>
+          <a:effectLst/>
+        </p:spPr>
+        <p:style>
+          <a:lnRef idx="1">
+            <a:schemeClr val="accent1"/>
+          </a:lnRef>
+          <a:fillRef idx="3">
+            <a:schemeClr val="accent1"/>
+          </a:fillRef>
+          <a:effectRef idx="2">
+            <a:schemeClr val="accent1"/>
+          </a:effectRef>
+          <a:fontRef idx="minor">
+            <a:schemeClr val="lt1"/>
+          </a:fontRef>
+        </p:style>
+        <p:txBody>
+          <a:bodyPr rtlCol="0" anchor="ctr"/>
+          <a:lstStyle/>
+          <a:p/>
+        </p:txBody>
+      </p:sp>
+      <p:sp>
+        <p:nvSpPr>
+          <p:cNvPr id="161" name="Rounded Rectangle 160"/>
+          <p:cNvSpPr/>
+          <p:nvPr/>
+        </p:nvSpPr>
+        <p:spPr>
+          <a:xfrm>
+            <a:off x="3209544" y="1280160"/>
+            <a:ext cx="2724912" cy="1664208"/>
+          </a:xfrm>
+          <a:prstGeom prst="roundRect">
+            <a:avLst>
+              <a:gd name="adj" fmla="val 6593"/>
+            </a:avLst>
+          </a:prstGeom>
+          <a:solidFill>
+            <a:srgbClr val="FFFFFF"/>
+          </a:solidFill>
+          <a:ln w="19050">
+            <a:solidFill>
+              <a:srgbClr val="111111"/>
+            </a:solidFill>
+          </a:ln>
+          <a:effectLst/>
+        </p:spPr>
+        <p:style>
+          <a:lnRef idx="1">
+            <a:schemeClr val="accent1"/>
+          </a:lnRef>
+          <a:fillRef idx="3">
+            <a:schemeClr val="accent1"/>
+          </a:fillRef>
+          <a:effectRef idx="2">
+            <a:schemeClr val="accent1"/>
+          </a:effectRef>
+          <a:fontRef idx="minor">
+            <a:schemeClr val="lt1"/>
+          </a:fontRef>
+        </p:style>
+        <p:txBody>
+          <a:bodyPr rtlCol="0" anchor="ctr"/>
+          <a:lstStyle/>
+          <a:p/>
+        </p:txBody>
+      </p:sp>
+      <p:sp>
+        <p:nvSpPr>
+          <p:cNvPr id="162" name="Rounded Rectangle 161"/>
+          <p:cNvSpPr/>
+          <p:nvPr/>
+        </p:nvSpPr>
+        <p:spPr>
+          <a:xfrm>
+            <a:off x="3383280" y="1463039"/>
+            <a:ext cx="475488" cy="475488"/>
+          </a:xfrm>
+          <a:prstGeom prst="roundRect">
+            <a:avLst>
+              <a:gd name="adj" fmla="val 24000"/>
+            </a:avLst>
+          </a:prstGeom>
+          <a:solidFill>
+            <a:srgbClr val="111111"/>
+          </a:solidFill>
+          <a:ln>
+            <a:noFill/>
+          </a:ln>
+          <a:effectLst/>
+        </p:spPr>
+        <p:style>
+          <a:lnRef idx="1">
+            <a:schemeClr val="accent1"/>
+          </a:lnRef>
+          <a:fillRef idx="3">
+            <a:schemeClr val="accent1"/>
+          </a:fillRef>
+          <a:effectRef idx="2">
+            <a:schemeClr val="accent1"/>
+          </a:effectRef>
+          <a:fontRef idx="minor">
+            <a:schemeClr val="lt1"/>
+          </a:fontRef>
+        </p:style>
+        <p:txBody>
+          <a:bodyPr rtlCol="0" anchor="ctr"/>
+          <a:lstStyle/>
+          <a:p/>
+        </p:txBody>
+      </p:sp>
+      <p:sp>
+        <p:nvSpPr>
+          <p:cNvPr id="163" name="Rounded Rectangle 162"/>
+          <p:cNvSpPr/>
+          <p:nvPr/>
+        </p:nvSpPr>
+        <p:spPr>
+          <a:xfrm>
+            <a:off x="3355848" y="1435607"/>
+            <a:ext cx="475488" cy="475488"/>
+          </a:xfrm>
+          <a:prstGeom prst="roundRect">
+            <a:avLst>
+              <a:gd name="adj" fmla="val 24000"/>
+            </a:avLst>
+          </a:prstGeom>
+          <a:solidFill>
+            <a:srgbClr val="FFD23F"/>
+          </a:solidFill>
+          <a:ln w="15875">
+            <a:solidFill>
+              <a:srgbClr val="111111"/>
+            </a:solidFill>
+          </a:ln>
+          <a:effectLst/>
+        </p:spPr>
+        <p:style>
+          <a:lnRef idx="1">
+            <a:schemeClr val="accent1"/>
+          </a:lnRef>
+          <a:fillRef idx="3">
+            <a:schemeClr val="accent1"/>
+          </a:fillRef>
+          <a:effectRef idx="2">
+            <a:schemeClr val="accent1"/>
+          </a:effectRef>
+          <a:fontRef idx="minor">
+            <a:schemeClr val="lt1"/>
+          </a:fontRef>
+        </p:style>
+        <p:txBody>
+          <a:bodyPr rtlCol="0" anchor="ctr"/>
+          <a:lstStyle/>
+          <a:p/>
+        </p:txBody>
+      </p:sp>
+      <p:pic>
+        <p:nvPicPr>
+          <p:cNvPr id="164" name="Picture 163" descr="l-log-in-ink.png"/>
+          <p:cNvPicPr>
+            <a:picLocks noChangeAspect="1"/>
+          </p:cNvPicPr>
+          <p:nvPr/>
+        </p:nvPicPr>
+        <p:blipFill>
+          <a:blip r:embed="rId6"/>
+          <a:stretch>
+            <a:fillRect/>
+          </a:stretch>
+        </p:blipFill>
+        <p:spPr>
+          <a:xfrm>
+            <a:off x="3450945" y="1530705"/>
+            <a:ext cx="285292" cy="285292"/>
+          </a:xfrm>
+          <a:prstGeom prst="rect">
+            <a:avLst/>
+          </a:prstGeom>
+        </p:spPr>
+      </p:pic>
+      <p:sp>
+        <p:nvSpPr>
+          <p:cNvPr id="165" name="Rounded Rectangle 164"/>
+          <p:cNvSpPr/>
+          <p:nvPr/>
+        </p:nvSpPr>
+        <p:spPr>
+          <a:xfrm>
+            <a:off x="4961224" y="1463039"/>
+            <a:ext cx="826928" cy="219456"/>
+          </a:xfrm>
+          <a:prstGeom prst="roundRect">
+            <a:avLst>
+              <a:gd name="adj" fmla="val 50000"/>
+            </a:avLst>
+          </a:prstGeom>
+          <a:solidFill>
+            <a:srgbClr val="111111"/>
+          </a:solidFill>
+          <a:ln w="15875">
+            <a:solidFill>
+              <a:srgbClr val="111111"/>
+            </a:solidFill>
+          </a:ln>
+          <a:effectLst/>
+        </p:spPr>
+        <p:style>
+          <a:lnRef idx="1">
+            <a:schemeClr val="accent1"/>
+          </a:lnRef>
+          <a:fillRef idx="3">
+            <a:schemeClr val="accent1"/>
+          </a:fillRef>
+          <a:effectRef idx="2">
+            <a:schemeClr val="accent1"/>
+          </a:effectRef>
+          <a:fontRef idx="minor">
+            <a:schemeClr val="lt1"/>
+          </a:fontRef>
+        </p:style>
+        <p:txBody>
+          <a:bodyPr rtlCol="0" anchor="ctr" lIns="54864" rIns="54864" tIns="0" bIns="0"/>
+          <a:lstStyle/>
+          <a:p>
+            <a:pPr algn="ctr"/>
+            <a:r>
+              <a:rPr sz="800" b="1">
+                <a:solidFill>
+                  <a:srgbClr val="FFFFFF"/>
+                </a:solidFill>
+                <a:latin typeface="Google Sans Flex"/>
+              </a:rPr>
+              <a:t>CART</a:t>
+            </a:r>
+          </a:p>
+        </p:txBody>
+      </p:sp>
+      <p:sp>
+        <p:nvSpPr>
+          <p:cNvPr id="166" name="TextBox 165"/>
+          <p:cNvSpPr txBox="1"/>
+          <p:nvPr/>
+        </p:nvSpPr>
+        <p:spPr>
+          <a:xfrm>
+            <a:off x="3355848" y="2029967"/>
+            <a:ext cx="2450592" cy="274320"/>
+          </a:xfrm>
+          <a:prstGeom prst="rect">
+            <a:avLst/>
+          </a:prstGeom>
+          <a:noFill/>
+        </p:spPr>
+        <p:txBody>
+          <a:bodyPr wrap="square" lIns="0" rIns="0" tIns="0" bIns="0" anchor="t">
+            <a:noAutofit/>
+          </a:bodyPr>
+          <a:lstStyle/>
+          <a:p>
+            <a:pPr algn="l">
+              <a:lnSpc>
+                <a:spcPct val="100000"/>
+              </a:lnSpc>
+              <a:spcAft>
+                <a:spcPts val="0"/>
+              </a:spcAft>
+            </a:pPr>
+            <a:r>
+              <a:rPr sz="1200" b="1">
+                <a:solidFill>
+                  <a:srgbClr val="111111"/>
+                </a:solidFill>
+                <a:latin typeface="Google Sans Flex"/>
+              </a:rPr>
+              <a:t>Flipkart</a:t>
+            </a:r>
+          </a:p>
+        </p:txBody>
+      </p:sp>
+      <p:sp>
+        <p:nvSpPr>
+          <p:cNvPr id="167" name="TextBox 166"/>
+          <p:cNvSpPr txBox="1"/>
+          <p:nvPr/>
+        </p:nvSpPr>
+        <p:spPr>
+          <a:xfrm>
+            <a:off x="3355848" y="2322576"/>
+            <a:ext cx="2450592" cy="594360"/>
+          </a:xfrm>
+          <a:prstGeom prst="rect">
+            <a:avLst/>
+          </a:prstGeom>
+          <a:noFill/>
+        </p:spPr>
+        <p:txBody>
+          <a:bodyPr wrap="square" lIns="0" rIns="0" tIns="0" bIns="0" anchor="t">
+            <a:noAutofit/>
+          </a:bodyPr>
+          <a:lstStyle/>
+          <a:p>
+            <a:pPr algn="l">
+              <a:lnSpc>
+                <a:spcPct val="105000"/>
+              </a:lnSpc>
+              <a:spcAft>
+                <a:spcPts val="0"/>
+              </a:spcAft>
+            </a:pPr>
+            <a:r>
+              <a:rPr sz="950" b="0">
+                <a:solidFill>
+                  <a:srgbClr val="3C4043"/>
+                </a:solidFill>
+                <a:latin typeface="Google Sans Flex"/>
+              </a:rPr>
+              <a:t>Reached the cart: a ₹10 platform fee the product page didn't show, sent for review. Later visits got an error page.</a:t>
+            </a:r>
+          </a:p>
+        </p:txBody>
+      </p:sp>
+      <p:sp>
+        <p:nvSpPr>
+          <p:cNvPr id="168" name="Rounded Rectangle 167"/>
+          <p:cNvSpPr/>
+          <p:nvPr/>
+        </p:nvSpPr>
+        <p:spPr>
+          <a:xfrm>
+            <a:off x="6144768" y="1325880"/>
+            <a:ext cx="2724912" cy="1664208"/>
+          </a:xfrm>
+          <a:prstGeom prst="roundRect">
+            <a:avLst>
+              <a:gd name="adj" fmla="val 6593"/>
+            </a:avLst>
+          </a:prstGeom>
+          <a:solidFill>
+            <a:srgbClr val="111111"/>
+          </a:solidFill>
+          <a:ln>
+            <a:noFill/>
+          </a:ln>
+          <a:effectLst/>
+        </p:spPr>
+        <p:style>
+          <a:lnRef idx="1">
+            <a:schemeClr val="accent1"/>
+          </a:lnRef>
+          <a:fillRef idx="3">
+            <a:schemeClr val="accent1"/>
+          </a:fillRef>
+          <a:effectRef idx="2">
+            <a:schemeClr val="accent1"/>
+          </a:effectRef>
+          <a:fontRef idx="minor">
+            <a:schemeClr val="lt1"/>
+          </a:fontRef>
+        </p:style>
+        <p:txBody>
+          <a:bodyPr rtlCol="0" anchor="ctr"/>
+          <a:lstStyle/>
+          <a:p/>
+        </p:txBody>
+      </p:sp>
+      <p:sp>
+        <p:nvSpPr>
+          <p:cNvPr id="169" name="Rounded Rectangle 168"/>
+          <p:cNvSpPr/>
+          <p:nvPr/>
+        </p:nvSpPr>
+        <p:spPr>
+          <a:xfrm>
+            <a:off x="6099048" y="1280160"/>
+            <a:ext cx="2724912" cy="1664208"/>
+          </a:xfrm>
+          <a:prstGeom prst="roundRect">
+            <a:avLst>
+              <a:gd name="adj" fmla="val 6593"/>
+            </a:avLst>
+          </a:prstGeom>
+          <a:solidFill>
+            <a:srgbClr val="FFFFFF"/>
+          </a:solidFill>
+          <a:ln w="19050">
+            <a:solidFill>
+              <a:srgbClr val="111111"/>
+            </a:solidFill>
+          </a:ln>
+          <a:effectLst/>
+        </p:spPr>
+        <p:style>
+          <a:lnRef idx="1">
+            <a:schemeClr val="accent1"/>
+          </a:lnRef>
+          <a:fillRef idx="3">
+            <a:schemeClr val="accent1"/>
+          </a:fillRef>
+          <a:effectRef idx="2">
+            <a:schemeClr val="accent1"/>
+          </a:effectRef>
+          <a:fontRef idx="minor">
+            <a:schemeClr val="lt1"/>
+          </a:fontRef>
+        </p:style>
+        <p:txBody>
+          <a:bodyPr rtlCol="0" anchor="ctr"/>
+          <a:lstStyle/>
+          <a:p/>
+        </p:txBody>
+      </p:sp>
+      <p:sp>
+        <p:nvSpPr>
+          <p:cNvPr id="170" name="Rounded Rectangle 169"/>
+          <p:cNvSpPr/>
+          <p:nvPr/>
+        </p:nvSpPr>
+        <p:spPr>
+          <a:xfrm>
+            <a:off x="6272784" y="1463039"/>
+            <a:ext cx="475488" cy="475488"/>
+          </a:xfrm>
+          <a:prstGeom prst="roundRect">
+            <a:avLst>
+              <a:gd name="adj" fmla="val 24000"/>
+            </a:avLst>
+          </a:prstGeom>
+          <a:solidFill>
+            <a:srgbClr val="111111"/>
+          </a:solidFill>
+          <a:ln>
+            <a:noFill/>
+          </a:ln>
+          <a:effectLst/>
+        </p:spPr>
+        <p:style>
+          <a:lnRef idx="1">
+            <a:schemeClr val="accent1"/>
+          </a:lnRef>
+          <a:fillRef idx="3">
+            <a:schemeClr val="accent1"/>
+          </a:fillRef>
+          <a:effectRef idx="2">
+            <a:schemeClr val="accent1"/>
+          </a:effectRef>
+          <a:fontRef idx="minor">
+            <a:schemeClr val="lt1"/>
+          </a:fontRef>
+        </p:style>
+        <p:txBody>
+          <a:bodyPr rtlCol="0" anchor="ctr"/>
+          <a:lstStyle/>
+          <a:p/>
+        </p:txBody>
+      </p:sp>
+      <p:sp>
+        <p:nvSpPr>
+          <p:cNvPr id="171" name="Rounded Rectangle 170"/>
+          <p:cNvSpPr/>
+          <p:nvPr/>
+        </p:nvSpPr>
+        <p:spPr>
+          <a:xfrm>
+            <a:off x="6245352" y="1435607"/>
+            <a:ext cx="475488" cy="475488"/>
+          </a:xfrm>
+          <a:prstGeom prst="roundRect">
+            <a:avLst>
+              <a:gd name="adj" fmla="val 24000"/>
+            </a:avLst>
+          </a:prstGeom>
+          <a:solidFill>
+            <a:srgbClr val="C4B5FD"/>
+          </a:solidFill>
+          <a:ln w="15875">
+            <a:solidFill>
+              <a:srgbClr val="111111"/>
+            </a:solidFill>
+          </a:ln>
+          <a:effectLst/>
+        </p:spPr>
+        <p:style>
+          <a:lnRef idx="1">
+            <a:schemeClr val="accent1"/>
+          </a:lnRef>
+          <a:fillRef idx="3">
+            <a:schemeClr val="accent1"/>
+          </a:fillRef>
+          <a:effectRef idx="2">
+            <a:schemeClr val="accent1"/>
+          </a:effectRef>
+          <a:fontRef idx="minor">
+            <a:schemeClr val="lt1"/>
+          </a:fontRef>
+        </p:style>
+        <p:txBody>
+          <a:bodyPr rtlCol="0" anchor="ctr"/>
+          <a:lstStyle/>
+          <a:p/>
+        </p:txBody>
+      </p:sp>
+      <p:pic>
+        <p:nvPicPr>
+          <p:cNvPr id="172" name="Picture 171" descr="l-calendar-clock-ink.png"/>
+          <p:cNvPicPr>
+            <a:picLocks noChangeAspect="1"/>
+          </p:cNvPicPr>
+          <p:nvPr/>
+        </p:nvPicPr>
+        <p:blipFill>
+          <a:blip r:embed="rId7"/>
+          <a:stretch>
+            <a:fillRect/>
+          </a:stretch>
+        </p:blipFill>
+        <p:spPr>
+          <a:xfrm>
+            <a:off x="6340449" y="1530705"/>
+            <a:ext cx="285292" cy="285292"/>
+          </a:xfrm>
+          <a:prstGeom prst="rect">
+            <a:avLst/>
+          </a:prstGeom>
+        </p:spPr>
+      </p:pic>
+      <p:sp>
+        <p:nvSpPr>
+          <p:cNvPr id="173" name="Rounded Rectangle 172"/>
+          <p:cNvSpPr/>
+          <p:nvPr/>
+        </p:nvSpPr>
+        <p:spPr>
+          <a:xfrm>
+            <a:off x="7850728" y="1463039"/>
+            <a:ext cx="826928" cy="219456"/>
+          </a:xfrm>
+          <a:prstGeom prst="roundRect">
+            <a:avLst>
+              <a:gd name="adj" fmla="val 50000"/>
+            </a:avLst>
+          </a:prstGeom>
+          <a:solidFill>
+            <a:srgbClr val="111111"/>
+          </a:solidFill>
+          <a:ln w="15875">
+            <a:solidFill>
+              <a:srgbClr val="111111"/>
+            </a:solidFill>
+          </a:ln>
+          <a:effectLst/>
+        </p:spPr>
+        <p:style>
+          <a:lnRef idx="1">
+            <a:schemeClr val="accent1"/>
+          </a:lnRef>
+          <a:fillRef idx="3">
+            <a:schemeClr val="accent1"/>
+          </a:fillRef>
+          <a:effectRef idx="2">
+            <a:schemeClr val="accent1"/>
+          </a:effectRef>
+          <a:fontRef idx="minor">
+            <a:schemeClr val="lt1"/>
+          </a:fontRef>
+        </p:style>
+        <p:txBody>
+          <a:bodyPr rtlCol="0" anchor="ctr" lIns="54864" rIns="54864" tIns="0" bIns="0"/>
+          <a:lstStyle/>
+          <a:p>
+            <a:pPr algn="ctr"/>
+            <a:r>
+              <a:rPr sz="800" b="1">
+                <a:solidFill>
+                  <a:srgbClr val="FFFFFF"/>
+                </a:solidFill>
+                <a:latin typeface="Google Sans Flex"/>
+              </a:rPr>
+              <a:t>SOLD OUT</a:t>
+            </a:r>
+          </a:p>
+        </p:txBody>
+      </p:sp>
+      <p:sp>
+        <p:nvSpPr>
+          <p:cNvPr id="174" name="TextBox 173"/>
+          <p:cNvSpPr txBox="1"/>
+          <p:nvPr/>
+        </p:nvSpPr>
+        <p:spPr>
+          <a:xfrm>
+            <a:off x="6245352" y="2029967"/>
+            <a:ext cx="2450592" cy="274320"/>
+          </a:xfrm>
+          <a:prstGeom prst="rect">
+            <a:avLst/>
+          </a:prstGeom>
+          <a:noFill/>
+        </p:spPr>
+        <p:txBody>
+          <a:bodyPr wrap="square" lIns="0" rIns="0" tIns="0" bIns="0" anchor="t">
+            <a:noAutofit/>
+          </a:bodyPr>
+          <a:lstStyle/>
+          <a:p>
+            <a:pPr algn="l">
+              <a:lnSpc>
+                <a:spcPct val="100000"/>
+              </a:lnSpc>
+              <a:spcAft>
+                <a:spcPts val="0"/>
+              </a:spcAft>
+            </a:pPr>
+            <a:r>
+              <a:rPr sz="1200" b="1">
+                <a:solidFill>
+                  <a:srgbClr val="111111"/>
+                </a:solidFill>
+                <a:latin typeface="Google Sans Flex"/>
+              </a:rPr>
+              <a:t>Blinkit</a:t>
+            </a:r>
+          </a:p>
+        </p:txBody>
+      </p:sp>
+      <p:sp>
+        <p:nvSpPr>
+          <p:cNvPr id="175" name="TextBox 174"/>
+          <p:cNvSpPr txBox="1"/>
+          <p:nvPr/>
+        </p:nvSpPr>
+        <p:spPr>
+          <a:xfrm>
+            <a:off x="6245352" y="2322576"/>
+            <a:ext cx="2450592" cy="594360"/>
+          </a:xfrm>
+          <a:prstGeom prst="rect">
+            <a:avLst/>
+          </a:prstGeom>
+          <a:noFill/>
+        </p:spPr>
+        <p:txBody>
+          <a:bodyPr wrap="square" lIns="0" rIns="0" tIns="0" bIns="0" anchor="t">
+            <a:noAutofit/>
+          </a:bodyPr>
+          <a:lstStyle/>
+          <a:p>
+            <a:pPr algn="l">
+              <a:lnSpc>
+                <a:spcPct val="105000"/>
+              </a:lnSpc>
+              <a:spcAft>
+                <a:spcPts val="0"/>
+              </a:spcAft>
+            </a:pPr>
+            <a:r>
+              <a:rPr sz="950" b="0">
+                <a:solidFill>
+                  <a:srgbClr val="3C4043"/>
+                </a:solidFill>
+                <a:latin typeface="Google Sans Flex"/>
+              </a:rPr>
+              <a:t>The product was out of stock, so the agent stopped instead of adding a similar one.</a:t>
+            </a:r>
+          </a:p>
+        </p:txBody>
+      </p:sp>
+      <p:sp>
+        <p:nvSpPr>
+          <p:cNvPr id="176" name="Rounded Rectangle 175"/>
+          <p:cNvSpPr/>
+          <p:nvPr/>
+        </p:nvSpPr>
+        <p:spPr>
+          <a:xfrm>
+            <a:off x="365759" y="3136391"/>
+            <a:ext cx="2724912" cy="1664208"/>
+          </a:xfrm>
+          <a:prstGeom prst="roundRect">
+            <a:avLst>
+              <a:gd name="adj" fmla="val 6593"/>
+            </a:avLst>
+          </a:prstGeom>
+          <a:solidFill>
+            <a:srgbClr val="111111"/>
+          </a:solidFill>
+          <a:ln>
+            <a:noFill/>
+          </a:ln>
+          <a:effectLst/>
+        </p:spPr>
+        <p:style>
+          <a:lnRef idx="1">
+            <a:schemeClr val="accent1"/>
+          </a:lnRef>
+          <a:fillRef idx="3">
+            <a:schemeClr val="accent1"/>
+          </a:fillRef>
+          <a:effectRef idx="2">
+            <a:schemeClr val="accent1"/>
+          </a:effectRef>
+          <a:fontRef idx="minor">
+            <a:schemeClr val="lt1"/>
+          </a:fontRef>
+        </p:style>
+        <p:txBody>
+          <a:bodyPr rtlCol="0" anchor="ctr"/>
+          <a:lstStyle/>
+          <a:p/>
+        </p:txBody>
+      </p:sp>
+      <p:sp>
+        <p:nvSpPr>
+          <p:cNvPr id="177" name="Rounded Rectangle 176"/>
+          <p:cNvSpPr/>
+          <p:nvPr/>
+        </p:nvSpPr>
+        <p:spPr>
+          <a:xfrm>
+            <a:off x="320040" y="3090672"/>
+            <a:ext cx="2724912" cy="1664208"/>
+          </a:xfrm>
+          <a:prstGeom prst="roundRect">
+            <a:avLst>
+              <a:gd name="adj" fmla="val 6593"/>
+            </a:avLst>
+          </a:prstGeom>
+          <a:solidFill>
+            <a:srgbClr val="FFFFFF"/>
+          </a:solidFill>
+          <a:ln w="19050">
+            <a:solidFill>
+              <a:srgbClr val="111111"/>
+            </a:solidFill>
+          </a:ln>
+          <a:effectLst/>
+        </p:spPr>
+        <p:style>
+          <a:lnRef idx="1">
+            <a:schemeClr val="accent1"/>
+          </a:lnRef>
+          <a:fillRef idx="3">
+            <a:schemeClr val="accent1"/>
+          </a:fillRef>
+          <a:effectRef idx="2">
+            <a:schemeClr val="accent1"/>
+          </a:effectRef>
+          <a:fontRef idx="minor">
+            <a:schemeClr val="lt1"/>
+          </a:fontRef>
+        </p:style>
+        <p:txBody>
+          <a:bodyPr rtlCol="0" anchor="ctr"/>
+          <a:lstStyle/>
+          <a:p/>
+        </p:txBody>
+      </p:sp>
+      <p:sp>
+        <p:nvSpPr>
+          <p:cNvPr id="178" name="Rounded Rectangle 177"/>
+          <p:cNvSpPr/>
+          <p:nvPr/>
+        </p:nvSpPr>
+        <p:spPr>
+          <a:xfrm>
+            <a:off x="493776" y="3273551"/>
+            <a:ext cx="475488" cy="475488"/>
+          </a:xfrm>
+          <a:prstGeom prst="roundRect">
+            <a:avLst>
+              <a:gd name="adj" fmla="val 24000"/>
+            </a:avLst>
+          </a:prstGeom>
+          <a:solidFill>
+            <a:srgbClr val="111111"/>
+          </a:solidFill>
+          <a:ln>
+            <a:noFill/>
+          </a:ln>
+          <a:effectLst/>
+        </p:spPr>
+        <p:style>
+          <a:lnRef idx="1">
+            <a:schemeClr val="accent1"/>
+          </a:lnRef>
+          <a:fillRef idx="3">
+            <a:schemeClr val="accent1"/>
+          </a:fillRef>
+          <a:effectRef idx="2">
+            <a:schemeClr val="accent1"/>
+          </a:effectRef>
+          <a:fontRef idx="minor">
+            <a:schemeClr val="lt1"/>
+          </a:fontRef>
+        </p:style>
+        <p:txBody>
+          <a:bodyPr rtlCol="0" anchor="ctr"/>
+          <a:lstStyle/>
+          <a:p/>
+        </p:txBody>
+      </p:sp>
+      <p:sp>
+        <p:nvSpPr>
+          <p:cNvPr id="179" name="Rounded Rectangle 178"/>
+          <p:cNvSpPr/>
+          <p:nvPr/>
+        </p:nvSpPr>
+        <p:spPr>
+          <a:xfrm>
+            <a:off x="466344" y="3246120"/>
+            <a:ext cx="475488" cy="475488"/>
+          </a:xfrm>
+          <a:prstGeom prst="roundRect">
+            <a:avLst>
+              <a:gd name="adj" fmla="val 24000"/>
+            </a:avLst>
+          </a:prstGeom>
+          <a:solidFill>
+            <a:srgbClr val="FF5CA8"/>
+          </a:solidFill>
+          <a:ln w="15875">
+            <a:solidFill>
+              <a:srgbClr val="111111"/>
+            </a:solidFill>
+          </a:ln>
+          <a:effectLst/>
+        </p:spPr>
+        <p:style>
+          <a:lnRef idx="1">
+            <a:schemeClr val="accent1"/>
+          </a:lnRef>
+          <a:fillRef idx="3">
+            <a:schemeClr val="accent1"/>
+          </a:fillRef>
+          <a:effectRef idx="2">
+            <a:schemeClr val="accent1"/>
+          </a:effectRef>
+          <a:fontRef idx="minor">
+            <a:schemeClr val="lt1"/>
+          </a:fontRef>
+        </p:style>
+        <p:txBody>
+          <a:bodyPr rtlCol="0" anchor="ctr"/>
+          <a:lstStyle/>
+          <a:p/>
+        </p:txBody>
+      </p:sp>
+      <p:pic>
+        <p:nvPicPr>
+          <p:cNvPr id="180" name="Picture 179" descr="l-puzzle-ink.png"/>
+          <p:cNvPicPr>
+            <a:picLocks noChangeAspect="1"/>
+          </p:cNvPicPr>
+          <p:nvPr/>
+        </p:nvPicPr>
+        <p:blipFill>
+          <a:blip r:embed="rId8"/>
+          <a:stretch>
+            <a:fillRect/>
+          </a:stretch>
+        </p:blipFill>
+        <p:spPr>
+          <a:xfrm>
+            <a:off x="561441" y="3341217"/>
+            <a:ext cx="285292" cy="285292"/>
+          </a:xfrm>
+          <a:prstGeom prst="rect">
+            <a:avLst/>
+          </a:prstGeom>
+        </p:spPr>
+      </p:pic>
+      <p:sp>
+        <p:nvSpPr>
+          <p:cNvPr id="181" name="Rounded Rectangle 180"/>
+          <p:cNvSpPr/>
+          <p:nvPr/>
+        </p:nvSpPr>
+        <p:spPr>
+          <a:xfrm>
+            <a:off x="2071720" y="3273552"/>
+            <a:ext cx="826928" cy="219456"/>
+          </a:xfrm>
+          <a:prstGeom prst="roundRect">
+            <a:avLst>
+              <a:gd name="adj" fmla="val 50000"/>
+            </a:avLst>
+          </a:prstGeom>
+          <a:solidFill>
+            <a:srgbClr val="FFFFFF"/>
+          </a:solidFill>
+          <a:ln w="15875">
+            <a:solidFill>
+              <a:srgbClr val="111111"/>
+            </a:solidFill>
+          </a:ln>
+          <a:effectLst/>
+        </p:spPr>
+        <p:style>
+          <a:lnRef idx="1">
+            <a:schemeClr val="accent1"/>
+          </a:lnRef>
+          <a:fillRef idx="3">
+            <a:schemeClr val="accent1"/>
+          </a:fillRef>
+          <a:effectRef idx="2">
+            <a:schemeClr val="accent1"/>
+          </a:effectRef>
+          <a:fontRef idx="minor">
+            <a:schemeClr val="lt1"/>
+          </a:fontRef>
+        </p:style>
+        <p:txBody>
+          <a:bodyPr rtlCol="0" anchor="ctr" lIns="54864" rIns="54864" tIns="0" bIns="0"/>
+          <a:lstStyle/>
+          <a:p>
+            <a:pPr algn="ctr"/>
+            <a:r>
+              <a:rPr sz="800" b="1">
+                <a:solidFill>
+                  <a:srgbClr val="111111"/>
+                </a:solidFill>
+                <a:latin typeface="Google Sans Flex"/>
+              </a:rPr>
+              <a:t>EMPTY</a:t>
+            </a:r>
+          </a:p>
+        </p:txBody>
+      </p:sp>
+      <p:sp>
+        <p:nvSpPr>
+          <p:cNvPr id="182" name="TextBox 181"/>
+          <p:cNvSpPr txBox="1"/>
+          <p:nvPr/>
+        </p:nvSpPr>
+        <p:spPr>
+          <a:xfrm>
+            <a:off x="466344" y="3840480"/>
+            <a:ext cx="2450592" cy="274320"/>
+          </a:xfrm>
+          <a:prstGeom prst="rect">
+            <a:avLst/>
+          </a:prstGeom>
+          <a:noFill/>
+        </p:spPr>
+        <p:txBody>
+          <a:bodyPr wrap="square" lIns="0" rIns="0" tIns="0" bIns="0" anchor="t">
+            <a:noAutofit/>
+          </a:bodyPr>
+          <a:lstStyle/>
+          <a:p>
+            <a:pPr algn="l">
+              <a:lnSpc>
+                <a:spcPct val="100000"/>
+              </a:lnSpc>
+              <a:spcAft>
+                <a:spcPts val="0"/>
+              </a:spcAft>
+            </a:pPr>
+            <a:r>
+              <a:rPr sz="1200" b="1">
+                <a:solidFill>
+                  <a:srgbClr val="111111"/>
+                </a:solidFill>
+                <a:latin typeface="Google Sans Flex"/>
+              </a:rPr>
+              <a:t>Zepto</a:t>
+            </a:r>
+          </a:p>
+        </p:txBody>
+      </p:sp>
+      <p:sp>
+        <p:nvSpPr>
+          <p:cNvPr id="183" name="TextBox 182"/>
+          <p:cNvSpPr txBox="1"/>
+          <p:nvPr/>
+        </p:nvSpPr>
+        <p:spPr>
+          <a:xfrm>
+            <a:off x="466344" y="4133087"/>
+            <a:ext cx="2450592" cy="594360"/>
+          </a:xfrm>
+          <a:prstGeom prst="rect">
+            <a:avLst/>
+          </a:prstGeom>
+          <a:noFill/>
+        </p:spPr>
+        <p:txBody>
+          <a:bodyPr wrap="square" lIns="0" rIns="0" tIns="0" bIns="0" anchor="t">
+            <a:noAutofit/>
+          </a:bodyPr>
+          <a:lstStyle/>
+          <a:p>
+            <a:pPr algn="l">
+              <a:lnSpc>
+                <a:spcPct val="105000"/>
+              </a:lnSpc>
+              <a:spcAft>
+                <a:spcPts val="0"/>
+              </a:spcAft>
+            </a:pPr>
+            <a:r>
+              <a:rPr sz="950" b="0">
+                <a:solidFill>
+                  <a:srgbClr val="3C4043"/>
+                </a:solidFill>
+                <a:latin typeface="Google Sans Flex"/>
+              </a:rPr>
+              <a:t>Fined by the CCPA in Aug 2026. Served our browser an empty page: reported as not checked, never as clean.</a:t>
+            </a:r>
+          </a:p>
+        </p:txBody>
+      </p:sp>
+      <p:sp>
+        <p:nvSpPr>
+          <p:cNvPr id="184" name="Rounded Rectangle 183"/>
+          <p:cNvSpPr/>
+          <p:nvPr/>
+        </p:nvSpPr>
+        <p:spPr>
+          <a:xfrm>
+            <a:off x="3255264" y="3136391"/>
+            <a:ext cx="2724912" cy="1664208"/>
+          </a:xfrm>
+          <a:prstGeom prst="roundRect">
+            <a:avLst>
+              <a:gd name="adj" fmla="val 6593"/>
+            </a:avLst>
+          </a:prstGeom>
+          <a:solidFill>
+            <a:srgbClr val="111111"/>
+          </a:solidFill>
+          <a:ln>
+            <a:noFill/>
+          </a:ln>
+          <a:effectLst/>
+        </p:spPr>
+        <p:style>
+          <a:lnRef idx="1">
+            <a:schemeClr val="accent1"/>
+          </a:lnRef>
+          <a:fillRef idx="3">
+            <a:schemeClr val="accent1"/>
+          </a:fillRef>
+          <a:effectRef idx="2">
+            <a:schemeClr val="accent1"/>
+          </a:effectRef>
+          <a:fontRef idx="minor">
+            <a:schemeClr val="lt1"/>
+          </a:fontRef>
+        </p:style>
+        <p:txBody>
+          <a:bodyPr rtlCol="0" anchor="ctr"/>
+          <a:lstStyle/>
+          <a:p/>
+        </p:txBody>
+      </p:sp>
+      <p:sp>
+        <p:nvSpPr>
+          <p:cNvPr id="185" name="Rounded Rectangle 184"/>
+          <p:cNvSpPr/>
+          <p:nvPr/>
+        </p:nvSpPr>
+        <p:spPr>
+          <a:xfrm>
+            <a:off x="3209544" y="3090672"/>
+            <a:ext cx="2724912" cy="1664208"/>
+          </a:xfrm>
+          <a:prstGeom prst="roundRect">
+            <a:avLst>
+              <a:gd name="adj" fmla="val 6593"/>
+            </a:avLst>
+          </a:prstGeom>
+          <a:solidFill>
+            <a:srgbClr val="FFFFFF"/>
+          </a:solidFill>
+          <a:ln w="19050">
+            <a:solidFill>
+              <a:srgbClr val="111111"/>
+            </a:solidFill>
+          </a:ln>
+          <a:effectLst/>
+        </p:spPr>
+        <p:style>
+          <a:lnRef idx="1">
+            <a:schemeClr val="accent1"/>
+          </a:lnRef>
+          <a:fillRef idx="3">
+            <a:schemeClr val="accent1"/>
+          </a:fillRef>
+          <a:effectRef idx="2">
+            <a:schemeClr val="accent1"/>
+          </a:effectRef>
+          <a:fontRef idx="minor">
+            <a:schemeClr val="lt1"/>
+          </a:fontRef>
+        </p:style>
+        <p:txBody>
+          <a:bodyPr rtlCol="0" anchor="ctr"/>
+          <a:lstStyle/>
+          <a:p/>
+        </p:txBody>
+      </p:sp>
+      <p:sp>
+        <p:nvSpPr>
+          <p:cNvPr id="186" name="Rounded Rectangle 185"/>
+          <p:cNvSpPr/>
+          <p:nvPr/>
+        </p:nvSpPr>
+        <p:spPr>
+          <a:xfrm>
+            <a:off x="3383280" y="3273551"/>
+            <a:ext cx="475488" cy="475488"/>
+          </a:xfrm>
+          <a:prstGeom prst="roundRect">
+            <a:avLst>
+              <a:gd name="adj" fmla="val 24000"/>
+            </a:avLst>
+          </a:prstGeom>
+          <a:solidFill>
+            <a:srgbClr val="111111"/>
+          </a:solidFill>
+          <a:ln>
+            <a:noFill/>
+          </a:ln>
+          <a:effectLst/>
+        </p:spPr>
+        <p:style>
+          <a:lnRef idx="1">
+            <a:schemeClr val="accent1"/>
+          </a:lnRef>
+          <a:fillRef idx="3">
+            <a:schemeClr val="accent1"/>
+          </a:fillRef>
+          <a:effectRef idx="2">
+            <a:schemeClr val="accent1"/>
+          </a:effectRef>
+          <a:fontRef idx="minor">
+            <a:schemeClr val="lt1"/>
+          </a:fontRef>
+        </p:style>
+        <p:txBody>
+          <a:bodyPr rtlCol="0" anchor="ctr"/>
+          <a:lstStyle/>
+          <a:p/>
+        </p:txBody>
+      </p:sp>
+      <p:sp>
+        <p:nvSpPr>
+          <p:cNvPr id="187" name="Rounded Rectangle 186"/>
+          <p:cNvSpPr/>
+          <p:nvPr/>
+        </p:nvSpPr>
+        <p:spPr>
+          <a:xfrm>
+            <a:off x="3355848" y="3246120"/>
+            <a:ext cx="475488" cy="475488"/>
+          </a:xfrm>
+          <a:prstGeom prst="roundRect">
+            <a:avLst>
+              <a:gd name="adj" fmla="val 24000"/>
+            </a:avLst>
+          </a:prstGeom>
+          <a:solidFill>
+            <a:srgbClr val="4ADE9A"/>
+          </a:solidFill>
+          <a:ln w="15875">
+            <a:solidFill>
+              <a:srgbClr val="111111"/>
+            </a:solidFill>
+          </a:ln>
+          <a:effectLst/>
+        </p:spPr>
+        <p:style>
+          <a:lnRef idx="1">
+            <a:schemeClr val="accent1"/>
+          </a:lnRef>
+          <a:fillRef idx="3">
+            <a:schemeClr val="accent1"/>
+          </a:fillRef>
+          <a:effectRef idx="2">
+            <a:schemeClr val="accent1"/>
+          </a:effectRef>
+          <a:fontRef idx="minor">
+            <a:schemeClr val="lt1"/>
+          </a:fontRef>
+        </p:style>
+        <p:txBody>
+          <a:bodyPr rtlCol="0" anchor="ctr"/>
+          <a:lstStyle/>
+          <a:p/>
+        </p:txBody>
+      </p:sp>
+      <p:pic>
+        <p:nvPicPr>
+          <p:cNvPr id="188" name="Picture 187" descr="l-layout-dashboard-ink.png"/>
+          <p:cNvPicPr>
+            <a:picLocks noChangeAspect="1"/>
+          </p:cNvPicPr>
+          <p:nvPr/>
+        </p:nvPicPr>
+        <p:blipFill>
+          <a:blip r:embed="rId9"/>
+          <a:stretch>
+            <a:fillRect/>
+          </a:stretch>
+        </p:blipFill>
+        <p:spPr>
+          <a:xfrm>
+            <a:off x="3450945" y="3341217"/>
+            <a:ext cx="285292" cy="285292"/>
+          </a:xfrm>
+          <a:prstGeom prst="rect">
+            <a:avLst/>
+          </a:prstGeom>
+        </p:spPr>
+      </p:pic>
+      <p:sp>
+        <p:nvSpPr>
+          <p:cNvPr id="189" name="Rounded Rectangle 188"/>
+          <p:cNvSpPr/>
+          <p:nvPr/>
+        </p:nvSpPr>
+        <p:spPr>
+          <a:xfrm>
+            <a:off x="4961224" y="3273552"/>
+            <a:ext cx="826928" cy="219456"/>
+          </a:xfrm>
+          <a:prstGeom prst="roundRect">
+            <a:avLst>
+              <a:gd name="adj" fmla="val 50000"/>
+            </a:avLst>
+          </a:prstGeom>
+          <a:solidFill>
+            <a:srgbClr val="FFFFFF"/>
+          </a:solidFill>
+          <a:ln w="15875">
+            <a:solidFill>
+              <a:srgbClr val="111111"/>
+            </a:solidFill>
+          </a:ln>
+          <a:effectLst/>
+        </p:spPr>
+        <p:style>
+          <a:lnRef idx="1">
+            <a:schemeClr val="accent1"/>
+          </a:lnRef>
+          <a:fillRef idx="3">
+            <a:schemeClr val="accent1"/>
+          </a:fillRef>
+          <a:effectRef idx="2">
+            <a:schemeClr val="accent1"/>
+          </a:effectRef>
+          <a:fontRef idx="minor">
+            <a:schemeClr val="lt1"/>
+          </a:fontRef>
+        </p:style>
+        <p:txBody>
+          <a:bodyPr rtlCol="0" anchor="ctr" lIns="54864" rIns="54864" tIns="0" bIns="0"/>
+          <a:lstStyle/>
+          <a:p>
+            <a:pPr algn="ctr"/>
+            <a:r>
+              <a:rPr sz="800" b="1">
+                <a:solidFill>
+                  <a:srgbClr val="111111"/>
+                </a:solidFill>
+                <a:latin typeface="Google Sans Flex"/>
+              </a:rPr>
+              <a:t>REFUSED</a:t>
+            </a:r>
+          </a:p>
+        </p:txBody>
+      </p:sp>
+      <p:sp>
+        <p:nvSpPr>
+          <p:cNvPr id="190" name="TextBox 189"/>
+          <p:cNvSpPr txBox="1"/>
+          <p:nvPr/>
+        </p:nvSpPr>
+        <p:spPr>
+          <a:xfrm>
+            <a:off x="3355848" y="3840480"/>
+            <a:ext cx="2450592" cy="274320"/>
+          </a:xfrm>
+          <a:prstGeom prst="rect">
+            <a:avLst/>
+          </a:prstGeom>
+          <a:noFill/>
+        </p:spPr>
+        <p:txBody>
+          <a:bodyPr wrap="square" lIns="0" rIns="0" tIns="0" bIns="0" anchor="t">
+            <a:noAutofit/>
+          </a:bodyPr>
+          <a:lstStyle/>
+          <a:p>
+            <a:pPr algn="l">
+              <a:lnSpc>
+                <a:spcPct val="100000"/>
+              </a:lnSpc>
+              <a:spcAft>
+                <a:spcPts val="0"/>
+              </a:spcAft>
+            </a:pPr>
+            <a:r>
+              <a:rPr sz="1200" b="1">
+                <a:solidFill>
+                  <a:srgbClr val="111111"/>
+                </a:solidFill>
+                <a:latin typeface="Google Sans Flex"/>
+              </a:rPr>
+              <a:t>Myntra</a:t>
+            </a:r>
+          </a:p>
+        </p:txBody>
+      </p:sp>
+      <p:sp>
+        <p:nvSpPr>
+          <p:cNvPr id="191" name="TextBox 190"/>
+          <p:cNvSpPr txBox="1"/>
+          <p:nvPr/>
+        </p:nvSpPr>
+        <p:spPr>
+          <a:xfrm>
+            <a:off x="3355848" y="4133087"/>
+            <a:ext cx="2450592" cy="594360"/>
+          </a:xfrm>
+          <a:prstGeom prst="rect">
+            <a:avLst/>
+          </a:prstGeom>
+          <a:noFill/>
+        </p:spPr>
+        <p:txBody>
+          <a:bodyPr wrap="square" lIns="0" rIns="0" tIns="0" bIns="0" anchor="t">
+            <a:noAutofit/>
+          </a:bodyPr>
+          <a:lstStyle/>
+          <a:p>
+            <a:pPr algn="l">
+              <a:lnSpc>
+                <a:spcPct val="105000"/>
+              </a:lnSpc>
+              <a:spcAft>
+                <a:spcPts val="0"/>
+              </a:spcAft>
+            </a:pPr>
+            <a:r>
+              <a:rPr sz="950" b="0">
+                <a:solidFill>
+                  <a:srgbClr val="3C4043"/>
+                </a:solidFill>
+                <a:latin typeface="Google Sans Flex"/>
+              </a:rPr>
+              <a:t>Refused the connection from an automated browser. Reported as such; the agent never gets around it.</a:t>
+            </a:r>
+          </a:p>
+        </p:txBody>
+      </p:sp>
+      <p:sp>
+        <p:nvSpPr>
+          <p:cNvPr id="192" name="Rounded Rectangle 191"/>
+          <p:cNvSpPr/>
+          <p:nvPr/>
+        </p:nvSpPr>
+        <p:spPr>
+          <a:xfrm>
+            <a:off x="6144768" y="3136391"/>
+            <a:ext cx="2724912" cy="1664208"/>
+          </a:xfrm>
+          <a:prstGeom prst="roundRect">
+            <a:avLst>
+              <a:gd name="adj" fmla="val 6593"/>
+            </a:avLst>
+          </a:prstGeom>
+          <a:solidFill>
+            <a:srgbClr val="111111"/>
+          </a:solidFill>
+          <a:ln>
+            <a:noFill/>
+          </a:ln>
+          <a:effectLst/>
+        </p:spPr>
+        <p:style>
+          <a:lnRef idx="1">
+            <a:schemeClr val="accent1"/>
+          </a:lnRef>
+          <a:fillRef idx="3">
+            <a:schemeClr val="accent1"/>
+          </a:fillRef>
+          <a:effectRef idx="2">
+            <a:schemeClr val="accent1"/>
+          </a:effectRef>
+          <a:fontRef idx="minor">
+            <a:schemeClr val="lt1"/>
+          </a:fontRef>
+        </p:style>
+        <p:txBody>
+          <a:bodyPr rtlCol="0" anchor="ctr"/>
+          <a:lstStyle/>
+          <a:p/>
+        </p:txBody>
+      </p:sp>
+      <p:sp>
+        <p:nvSpPr>
+          <p:cNvPr id="193" name="Rounded Rectangle 192"/>
+          <p:cNvSpPr/>
+          <p:nvPr/>
+        </p:nvSpPr>
+        <p:spPr>
+          <a:xfrm>
+            <a:off x="6099048" y="3090672"/>
+            <a:ext cx="2724912" cy="1664208"/>
+          </a:xfrm>
+          <a:prstGeom prst="roundRect">
+            <a:avLst>
+              <a:gd name="adj" fmla="val 6593"/>
+            </a:avLst>
+          </a:prstGeom>
+          <a:solidFill>
+            <a:srgbClr val="FFFFFF"/>
+          </a:solidFill>
+          <a:ln w="19050">
+            <a:solidFill>
+              <a:srgbClr val="111111"/>
+            </a:solidFill>
+          </a:ln>
+          <a:effectLst/>
+        </p:spPr>
+        <p:style>
+          <a:lnRef idx="1">
+            <a:schemeClr val="accent1"/>
+          </a:lnRef>
+          <a:fillRef idx="3">
+            <a:schemeClr val="accent1"/>
+          </a:fillRef>
+          <a:effectRef idx="2">
+            <a:schemeClr val="accent1"/>
+          </a:effectRef>
+          <a:fontRef idx="minor">
+            <a:schemeClr val="lt1"/>
+          </a:fontRef>
+        </p:style>
+        <p:txBody>
+          <a:bodyPr rtlCol="0" anchor="ctr"/>
+          <a:lstStyle/>
+          <a:p/>
+        </p:txBody>
+      </p:sp>
+      <p:sp>
+        <p:nvSpPr>
+          <p:cNvPr id="194" name="Rounded Rectangle 193"/>
+          <p:cNvSpPr/>
+          <p:nvPr/>
+        </p:nvSpPr>
+        <p:spPr>
+          <a:xfrm>
+            <a:off x="6272784" y="3273551"/>
+            <a:ext cx="475488" cy="475488"/>
+          </a:xfrm>
+          <a:prstGeom prst="roundRect">
+            <a:avLst>
+              <a:gd name="adj" fmla="val 24000"/>
+            </a:avLst>
+          </a:prstGeom>
+          <a:solidFill>
+            <a:srgbClr val="111111"/>
+          </a:solidFill>
+          <a:ln>
+            <a:noFill/>
+          </a:ln>
+          <a:effectLst/>
+        </p:spPr>
+        <p:style>
+          <a:lnRef idx="1">
+            <a:schemeClr val="accent1"/>
+          </a:lnRef>
+          <a:fillRef idx="3">
+            <a:schemeClr val="accent1"/>
+          </a:fillRef>
+          <a:effectRef idx="2">
+            <a:schemeClr val="accent1"/>
+          </a:effectRef>
+          <a:fontRef idx="minor">
+            <a:schemeClr val="lt1"/>
+          </a:fontRef>
+        </p:style>
+        <p:txBody>
+          <a:bodyPr rtlCol="0" anchor="ctr"/>
+          <a:lstStyle/>
+          <a:p/>
+        </p:txBody>
+      </p:sp>
+      <p:sp>
+        <p:nvSpPr>
+          <p:cNvPr id="195" name="Rounded Rectangle 194"/>
+          <p:cNvSpPr/>
+          <p:nvPr/>
+        </p:nvSpPr>
+        <p:spPr>
+          <a:xfrm>
+            <a:off x="6245352" y="3246120"/>
+            <a:ext cx="475488" cy="475488"/>
+          </a:xfrm>
+          <a:prstGeom prst="roundRect">
+            <a:avLst>
+              <a:gd name="adj" fmla="val 24000"/>
+            </a:avLst>
+          </a:prstGeom>
+          <a:solidFill>
+            <a:srgbClr val="FFB38A"/>
+          </a:solidFill>
+          <a:ln w="15875">
+            <a:solidFill>
+              <a:srgbClr val="111111"/>
+            </a:solidFill>
+          </a:ln>
+          <a:effectLst/>
+        </p:spPr>
+        <p:style>
+          <a:lnRef idx="1">
+            <a:schemeClr val="accent1"/>
+          </a:lnRef>
+          <a:fillRef idx="3">
+            <a:schemeClr val="accent1"/>
+          </a:fillRef>
+          <a:effectRef idx="2">
+            <a:schemeClr val="accent1"/>
+          </a:effectRef>
+          <a:fontRef idx="minor">
+            <a:schemeClr val="lt1"/>
+          </a:fontRef>
+        </p:style>
+        <p:txBody>
+          <a:bodyPr rtlCol="0" anchor="ctr"/>
+          <a:lstStyle/>
+          <a:p/>
+        </p:txBody>
+      </p:sp>
+      <p:pic>
+        <p:nvPicPr>
+          <p:cNvPr id="196" name="Picture 195" descr="l-languages-ink.png"/>
+          <p:cNvPicPr>
+            <a:picLocks noChangeAspect="1"/>
+          </p:cNvPicPr>
+          <p:nvPr/>
+        </p:nvPicPr>
+        <p:blipFill>
+          <a:blip r:embed="rId10"/>
+          <a:stretch>
+            <a:fillRect/>
+          </a:stretch>
+        </p:blipFill>
+        <p:spPr>
+          <a:xfrm>
+            <a:off x="6340449" y="3341217"/>
+            <a:ext cx="285292" cy="285292"/>
+          </a:xfrm>
+          <a:prstGeom prst="rect">
+            <a:avLst/>
+          </a:prstGeom>
+        </p:spPr>
+      </p:pic>
+      <p:sp>
+        <p:nvSpPr>
+          <p:cNvPr id="197" name="Rounded Rectangle 196"/>
+          <p:cNvSpPr/>
+          <p:nvPr/>
+        </p:nvSpPr>
+        <p:spPr>
+          <a:xfrm>
+            <a:off x="7850728" y="3273552"/>
+            <a:ext cx="826928" cy="219456"/>
+          </a:xfrm>
+          <a:prstGeom prst="roundRect">
+            <a:avLst>
+              <a:gd name="adj" fmla="val 50000"/>
+            </a:avLst>
+          </a:prstGeom>
+          <a:solidFill>
+            <a:srgbClr val="FFFFFF"/>
+          </a:solidFill>
+          <a:ln w="15875">
+            <a:solidFill>
+              <a:srgbClr val="111111"/>
+            </a:solidFill>
+          </a:ln>
+          <a:effectLst/>
+        </p:spPr>
+        <p:style>
+          <a:lnRef idx="1">
+            <a:schemeClr val="accent1"/>
+          </a:lnRef>
+          <a:fillRef idx="3">
+            <a:schemeClr val="accent1"/>
+          </a:fillRef>
+          <a:effectRef idx="2">
+            <a:schemeClr val="accent1"/>
+          </a:effectRef>
+          <a:fontRef idx="minor">
+            <a:schemeClr val="lt1"/>
+          </a:fontRef>
+        </p:style>
+        <p:txBody>
+          <a:bodyPr rtlCol="0" anchor="ctr" lIns="54864" rIns="54864" tIns="0" bIns="0"/>
+          <a:lstStyle/>
+          <a:p>
+            <a:pPr algn="ctr"/>
+            <a:r>
+              <a:rPr sz="800" b="1">
+                <a:solidFill>
+                  <a:srgbClr val="111111"/>
+                </a:solidFill>
+                <a:latin typeface="Google Sans Flex"/>
+              </a:rPr>
+              <a:t>BOT WALL</a:t>
+            </a:r>
+          </a:p>
+        </p:txBody>
+      </p:sp>
+      <p:sp>
+        <p:nvSpPr>
+          <p:cNvPr id="198" name="TextBox 197"/>
+          <p:cNvSpPr txBox="1"/>
+          <p:nvPr/>
+        </p:nvSpPr>
+        <p:spPr>
+          <a:xfrm>
+            <a:off x="6245352" y="3840480"/>
+            <a:ext cx="2450592" cy="274320"/>
+          </a:xfrm>
+          <a:prstGeom prst="rect">
+            <a:avLst/>
+          </a:prstGeom>
+          <a:noFill/>
+        </p:spPr>
+        <p:txBody>
+          <a:bodyPr wrap="square" lIns="0" rIns="0" tIns="0" bIns="0" anchor="t">
+            <a:noAutofit/>
+          </a:bodyPr>
+          <a:lstStyle/>
+          <a:p>
+            <a:pPr algn="l">
+              <a:lnSpc>
+                <a:spcPct val="100000"/>
+              </a:lnSpc>
+              <a:spcAft>
+                <a:spcPts val="0"/>
+              </a:spcAft>
+            </a:pPr>
+            <a:r>
+              <a:rPr sz="1200" b="1">
+                <a:solidFill>
+                  <a:srgbClr val="111111"/>
+                </a:solidFill>
+                <a:latin typeface="Google Sans Flex"/>
+              </a:rPr>
+              <a:t>Meesho</a:t>
+            </a:r>
+          </a:p>
+        </p:txBody>
+      </p:sp>
+      <p:sp>
+        <p:nvSpPr>
+          <p:cNvPr id="199" name="TextBox 198"/>
+          <p:cNvSpPr txBox="1"/>
+          <p:nvPr/>
+        </p:nvSpPr>
+        <p:spPr>
+          <a:xfrm>
+            <a:off x="6245352" y="4133087"/>
+            <a:ext cx="2450592" cy="594360"/>
+          </a:xfrm>
+          <a:prstGeom prst="rect">
+            <a:avLst/>
+          </a:prstGeom>
+          <a:noFill/>
+        </p:spPr>
+        <p:txBody>
+          <a:bodyPr wrap="square" lIns="0" rIns="0" tIns="0" bIns="0" anchor="t">
+            <a:noAutofit/>
+          </a:bodyPr>
+          <a:lstStyle/>
+          <a:p>
+            <a:pPr algn="l">
+              <a:lnSpc>
+                <a:spcPct val="105000"/>
+              </a:lnSpc>
+              <a:spcAft>
+                <a:spcPts val="0"/>
+              </a:spcAft>
+            </a:pPr>
+            <a:r>
+              <a:rPr sz="950" b="0">
+                <a:solidFill>
+                  <a:srgbClr val="3C4043"/>
+                </a:solidFill>
+                <a:latin typeface="Google Sans Flex"/>
+              </a:rPr>
+              <a:t>Bot protection stopped the agent on the first page. Reported as such, never as clean.</a:t>
+            </a:r>
+          </a:p>
+        </p:txBody>
+      </p:sp>
+      <p:sp>
+        <p:nvSpPr>
+          <p:cNvPr id="250" name="Takeaway"/>
+          <p:cNvSpPr txBox="1"/>
+          <p:nvPr/>
+        </p:nvSpPr>
+        <p:spPr>
+          <a:xfrm>
+            <a:off x="320040" y="4815840"/>
+            <a:ext cx="8549640" cy="247650"/>
+          </a:xfrm>
+          <a:prstGeom prst="rect">
+            <a:avLst/>
+          </a:prstGeom>
+          <a:noFill/>
+        </p:spPr>
+        <p:txBody>
+          <a:bodyPr wrap="square" lIns="0" rIns="0" tIns="0" bIns="0" anchor="t">
+            <a:noAutofit/>
+          </a:bodyPr>
+          <a:lstStyle/>
+          <a:p>
+            <a:pPr algn="l">
+              <a:lnSpc>
+                <a:spcPct val="105000"/>
+              </a:lnSpc>
+              <a:spcAft>
+                <a:spcPts val="0"/>
+              </a:spcAft>
+            </a:pPr>
+            <a:r>
+              <a:rPr sz="950" b="1">
+                <a:solidFill>
+                  <a:srgbClr val="111111"/>
+                </a:solidFill>
+                <a:latin typeface="Google Sans Flex"/>
+              </a:rPr>
+              <a:t>Never once wrongly called clean. Outside audits get blocked, so the audit belongs on the platform's side, before release.</a:t>
+            </a:r>
+          </a:p>
+        </p:txBody>
+      </p:sp>
+    </p:spTree>
+  </p:cSld>
+  <p:clrMapOvr>
+    <a:masterClrMapping/>
+  </p:clrMapOvr>
+</p:sld>
+</file>
+
 <file path=ppt/slides/slide3.xml><?xml version="1.0" encoding="utf-8"?>
 <p:sld xmlns:a="http://schemas.openxmlformats.org/drawingml/2006/main" xmlns:r="http://schemas.openxmlformats.org/officeDocument/2006/relationships" xmlns:mc="http://schemas.openxmlformats.org/markup-compatibility/2006" xmlns:mv="urn:schemas-microsoft-com:mac:vml" xmlns:p="http://schemas.openxmlformats.org/presentationml/2006/main" xmlns:c="http://schemas.openxmlformats.org/drawingml/2006/chart" xmlns:dgm="http://schemas.openxmlformats.org/drawingml/2006/diagram" xmlns:o="urn:schemas-microsoft-com:office:office" xmlns:v="urn:schemas-microsoft-com:vml" xmlns:pvml="urn:schemas-microsoft-com:office:powerpoint" xmlns:com="http://schemas.openxmlformats.org/drawingml/2006/compatibility" xmlns:p14="http://schemas.microsoft.com/office/powerpoint/2010/main" xmlns:p15="http://schemas.microsoft.com/office/powerpoint/2012/main" xmlns:ahyp="http://schemas.microsoft.com/office/drawing/2018/hyperlinkcolor">
   <p:cSld>
@@ -18209,7 +20746,7 @@
                 </a:solidFill>
                 <a:latin typeface="Google Sans Flex"/>
               </a:rPr>
-              <a:t>Same earbuds. Insurance sneaked into the cart, a pre-ticked membership and fees shown only at payment. The price you see isn't the price you pay.</a:t>
+              <a:t>Our rigged test store, same earbuds: insurance sneaked into the cart, a pre-ticked membership and fees shown only at payment. The price you see isn't the price you pay.</a:t>
             </a:r>
           </a:p>
         </p:txBody>
@@ -18743,7 +21280,7 @@
                 </a:solidFill>
                 <a:latin typeface="Google Sans Flex"/>
               </a:rPr>
-              <a:t>AI agents shop like a real customer, and hand you the receipts.</a:t>
+              <a:t>AI agents shop your store like a real customer, and fix what they find.</a:t>
             </a:r>
           </a:p>
         </p:txBody>
@@ -21506,6 +24043,43 @@
               <a:t>see the real price and every trick before paying.</a:t>
             </a:r>
           </a:p>
+          <a:p>
+            <a:pPr algn="l">
+              <a:lnSpc>
+                <a:spcPct val="105000"/>
+              </a:lnSpc>
+              <a:spcAft>
+                <a:spcPts val="1000"/>
+              </a:spcAft>
+            </a:pPr>
+            <a:r>
+              <a:rPr sz="850" b="0">
+                <a:solidFill>
+                  <a:srgbClr val="111111"/>
+                </a:solidFill>
+                <a:latin typeface="Google Sans Flex"/>
+              </a:rPr>
+              <a:t>■  </a:t>
+            </a:r>
+            <a:r>
+              <a:rPr sz="1050" b="1">
+                <a:solidFill>
+                  <a:srgbClr val="111111"/>
+                </a:solidFill>
+                <a:latin typeface="Google Sans Flex"/>
+              </a:rPr>
+              <a:t>Who pays: </a:t>
+            </a:r>
+            <a:r>
+              <a:rPr sz="1050" b="0">
+                <a:solidFill>
+                  <a:srgbClr val="111111"/>
+                </a:solidFill>
+                <a:latin typeface="Google Sans Flex"/>
+              </a:rPr>
+              <a:t>platforms, per monitored product; consumer groups and regulators use it free.</a:t>
+            </a:r>
+          </a:p>
         </p:txBody>
       </p:sp>
       <p:sp>
@@ -26786,7 +29360,7 @@
                 </a:solidFill>
                 <a:latin typeface="Google Sans Flex"/>
               </a:rPr>
-              <a:t>measure first, then let Gemini judge, then double-check</a:t>
+              <a:t>an ADK agent graph: measure first, then Gemini judges, then an agent re-checks with tools</a:t>
             </a:r>
           </a:p>
         </p:txBody>
@@ -29979,7 +32553,7 @@
       </p:sp>
       <p:pic>
         <p:nvPicPr>
-          <p:cNvPr id="134" name="Picture 133" descr="Get the receipts"/>
+          <p:cNvPr id="134" name="Picture 133" descr="Get the report, then Fix it"/>
           <p:cNvPicPr>
             <a:picLocks noChangeAspect="1"/>
           </p:cNvPicPr>
@@ -30124,7 +32698,7 @@
                 </a:solidFill>
                 <a:latin typeface="Google Sans Flex"/>
               </a:rPr>
-              <a:t>Get the receipts</a:t>
+              <a:t>Get the report, then Fix it</a:t>
             </a:r>
           </a:p>
         </p:txBody>

</xml_diff>

<commit_message>
docs: add competition presentation files and remove legacy demo video assets
</commit_message>
<xml_diff>
--- a/Zero Context - Shop Honest - AI Builder Cup.pptx
+++ b/Zero Context - Shop Honest - AI Builder Cup.pptx
@@ -15785,7 +15785,9 @@
       </p:sp>
       <p:pic>
         <p:nvPicPr>
-          <p:cNvPr id="178" name="Picture 177" descr="l-play-ink.png"/>
+          <p:cNvPr id="178" name="Picture 177" descr="Play the Shop Honest demo video on YouTube">
+            <a:hlinkClick r:id="rId13"/>
+          </p:cNvPr>
           <p:cNvPicPr>
             <a:picLocks noChangeAspect="1"/>
           </p:cNvPicPr>
@@ -15838,13 +15840,14 @@
               </a:spcAft>
             </a:pPr>
             <a:r>
-              <a:rPr sz="1000" b="0">
+              <a:rPr sz="1000" b="0" u="sng">
                 <a:solidFill>
-                  <a:srgbClr val="5F6368"/>
+                  <a:srgbClr val="0097A7"/>
                 </a:solidFill>
                 <a:latin typeface="Google Sans Flex SemiBold"/>
+                <a:hlinkClick r:id="rId13" tooltip="Watch the Shop Honest product walkthrough on YouTube"/>
               </a:rPr>
-              <a:t>add the video link here</a:t>
+              <a:t>youtu.be/_mG4SobZ9E0</a:t>
             </a:r>
           </a:p>
         </p:txBody>
@@ -15886,7 +15889,7 @@
                 </a:solidFill>
                 <a:latin typeface="Google Sans Flex Medium"/>
               </a:rPr>
-              <a:t>A 3-minute walkthrough</a:t>
+              <a:t>A 2:54 product walkthrough</a:t>
             </a:r>
           </a:p>
         </p:txBody>

</xml_diff>